<commit_message>
Add speaker notes to every slide of the review deck
Each of the 15 slides now carries a notes page written for a spoken
walkthrough: a timing cue, the argument to make, the numbers to say out
loud, and the transitions between sections. Slides 5, 6 and 13 carry the
longest notes since they hold the diagnosis, the case evidence and the
synthesis.

Regenerating the notes parts also fixed two package defects the earlier
build left behind: duplicate content-type overrides for the slide parts,
and a stale notes relationship on slide 1 that made it reference its
notes page twice. Both came from a relationship-stripping regex that
stopped at the first slash inside an attribute value.

Co-Authored-By: Claude Opus 5 <noreply@anthropic.com>
Claude-Session: https://claude.ai/code/session_01DmRwKq1C8FAK922HWA5C5g
</commit_message>
<xml_diff>
--- a/Bunker_Biofuel_Manager_Review.pptx
+++ b/Bunker_Biofuel_Manager_Review.pptx
@@ -311,15 +311,10 @@
             <a:spLocks noGrp="1" noRot="1" noChangeAspect="1"/>
           </p:cNvSpPr>
           <p:nvPr>
-            <p:ph type="sldImg"/>
+            <p:ph type="sldImg" idx="2"/>
           </p:nvPr>
         </p:nvSpPr>
-        <p:spPr>
-          <a:xfrm>
-            <a:off x="381000" y="685800"/>
-            <a:ext cx="6096000" cy="3429000"/>
-          </a:xfrm>
-        </p:spPr>
+        <p:spPr/>
       </p:sp>
       <p:sp>
         <p:nvSpPr>
@@ -328,7 +323,7 @@
             <a:spLocks noGrp="1"/>
           </p:cNvSpPr>
           <p:nvPr>
-            <p:ph type="body" idx="1"/>
+            <p:ph type="body" sz="quarter" idx="3"/>
           </p:nvPr>
         </p:nvSpPr>
         <p:spPr/>
@@ -336,7 +331,46 @@
           <a:bodyPr/>
           <a:lstStyle/>
           <a:p>
-            <a:endParaRPr lang="en-US" dirty="0"/>
+            <a:r>
+              <a:rPr lang="ko-KR" altLang="en-US" dirty="0"/>
+              <a:t>[오프닝 · 약 1분]</a:t>
+            </a:r>
+          </a:p>
+          <a:p>
+            <a:endParaRPr lang="ko-KR" altLang="en-US" dirty="0"/>
+          </a:p>
+          <a:p>
+            <a:r>
+              <a:rPr lang="ko-KR" altLang="en-US" dirty="0"/>
+              <a:t>오늘 공유드릴 건 두 개의 최신 리포트입니다. 하나는 Gard가 올해 8월에 낸 'Beyond Specification — 2026년 초 벙커 클레임 인사이트'이고, 다른 하나는 싱가포르선주협회(SSA)가 2026년 8월에 개정한 바이오연료 벙커링 FAQ입니다.</a:t>
+            </a:r>
+          </a:p>
+          <a:p>
+            <a:endParaRPr lang="ko-KR" altLang="en-US" dirty="0"/>
+          </a:p>
+          <a:p>
+            <a:r>
+              <a:rPr lang="ko-KR" altLang="en-US" dirty="0"/>
+              <a:t>두 문서를 따로 읽으면 각각 별개의 이슈로 보이는데, 같이 놓고 보면 하나의 흐름으로 이어집니다. 그래서 오늘은 문서를 순서대로 요약하는 대신, 네 덩어리로 나눠서 말씀드리겠습니다.</a:t>
+            </a:r>
+          </a:p>
+          <a:p>
+            <a:endParaRPr lang="ko-KR" altLang="en-US" dirty="0"/>
+          </a:p>
+          <a:p>
+            <a:r>
+              <a:rPr lang="ko-KR" altLang="en-US" dirty="0"/>
+              <a:t>앞의 두 파트는 '지금 무슨 일이 벌어지고 있나', 세 번째는 '바이오연료 전환이 여기에 어떻게 얹히나', 마지막이 '그래서 우리는 뭘 해야 하나'입니다.</a:t>
+            </a:r>
+          </a:p>
+          <a:p>
+            <a:endParaRPr lang="ko-KR" altLang="en-US" dirty="0"/>
+          </a:p>
+          <a:p>
+            <a:r>
+              <a:rPr lang="ko-KR" altLang="en-US" dirty="0"/>
+              <a:t>전체 20분 정도 예상하고, 13번 슬라이드가 오늘의 핵심이니 거기서 조금 더 시간을 쓰겠습니다. 마지막에 결정을 부탁드릴 사항이 세 가지 있습니다.</a:t>
+            </a:r>
           </a:p>
         </p:txBody>
       </p:sp>
@@ -347,90 +381,1843 @@
             <a:spLocks noGrp="1"/>
           </p:cNvSpPr>
           <p:nvPr>
-            <p:ph type="sldNum" sz="quarter" idx="10"/>
+            <p:ph type="sldNum" sz="quarter" idx="5"/>
           </p:nvPr>
         </p:nvSpPr>
         <p:spPr/>
+      </p:sp>
+    </p:spTree>
+  </p:cSld>
+  <p:clrMapOvr>
+    <a:masterClrMapping/>
+  </p:clrMapOvr>
+</p:notes>
+</file>
+
+<file path=ppt/notesSlides/notesSlide10.xml><?xml version="1.0" encoding="utf-8"?>
+<p:notes xmlns:a="http://schemas.openxmlformats.org/drawingml/2006/main" xmlns:r="http://schemas.openxmlformats.org/officeDocument/2006/relationships" xmlns:p="http://schemas.openxmlformats.org/presentationml/2006/main">
+  <p:cSld>
+    <p:spTree>
+      <p:nvGrpSpPr>
+        <p:cNvPr id="1" name=""/>
+        <p:cNvGrpSpPr/>
+        <p:nvPr/>
+      </p:nvGrpSpPr>
+      <p:grpSpPr>
+        <a:xfrm>
+          <a:off x="0" y="0"/>
+          <a:ext cx="0" cy="0"/>
+          <a:chOff x="0" y="0"/>
+          <a:chExt cx="0" cy="0"/>
+        </a:xfrm>
+      </p:grpSpPr>
+      <p:sp>
+        <p:nvSpPr>
+          <p:cNvPr id="2" name="Slide Image Placeholder 1"/>
+          <p:cNvSpPr>
+            <a:spLocks noGrp="1" noRot="1" noChangeAspect="1"/>
+          </p:cNvSpPr>
+          <p:nvPr>
+            <p:ph type="sldImg" idx="2"/>
+          </p:nvPr>
+        </p:nvSpPr>
+        <p:spPr/>
+      </p:sp>
+      <p:sp>
+        <p:nvSpPr>
+          <p:cNvPr id="3" name="Notes Placeholder 2"/>
+          <p:cNvSpPr>
+            <a:spLocks noGrp="1"/>
+          </p:cNvSpPr>
+          <p:nvPr>
+            <p:ph type="body" sz="quarter" idx="3"/>
+          </p:nvPr>
+        </p:nvSpPr>
+        <p:spPr/>
         <p:txBody>
           <a:bodyPr/>
           <a:lstStyle/>
           <a:p>
-            <a:pPr marL="0" marR="0" lvl="0" indent="0" algn="l" defTabSz="914400" rtl="0" eaLnBrk="1" fontAlgn="auto" latinLnBrk="0" hangingPunct="1">
-              <a:lnSpc>
-                <a:spcPct val="100000"/>
-              </a:lnSpc>
-              <a:spcBef>
-                <a:spcPts val="0"/>
-              </a:spcBef>
-              <a:spcAft>
-                <a:spcPts val="0"/>
-              </a:spcAft>
-              <a:buClrTx/>
-              <a:buSzTx/>
-              <a:buFontTx/>
-              <a:buNone/>
-              <a:tabLst/>
-              <a:defRPr/>
-            </a:pPr>
-            <a:fld id="{F7021451-1387-4CA6-816F-3879F97B5CBC}" type="slidenum">
-              <a:rPr kumimoji="0" lang="en-US" sz="1800" b="0" i="0" u="none" strike="noStrike" kern="1200" cap="none" spc="0" normalizeH="0" baseline="0" noProof="0">
-                <a:ln>
-                  <a:noFill/>
-                </a:ln>
-                <a:solidFill>
-                  <a:prstClr val="black"/>
-                </a:solidFill>
-                <a:effectLst/>
-                <a:uLnTx/>
-                <a:uFillTx/>
-                <a:latin typeface="Aptos" panose="02110004020202020204"/>
-                <a:ea typeface="+mn-ea"/>
-                <a:cs typeface="Arial"/>
-                <a:sym typeface="Arial"/>
-              </a:rPr>
-              <a:pPr marL="0" marR="0" lvl="0" indent="0" algn="l" defTabSz="914400" rtl="0" eaLnBrk="1" fontAlgn="auto" latinLnBrk="0" hangingPunct="1">
-                <a:lnSpc>
-                  <a:spcPct val="100000"/>
-                </a:lnSpc>
-                <a:spcBef>
-                  <a:spcPts val="0"/>
-                </a:spcBef>
-                <a:spcAft>
-                  <a:spcPts val="0"/>
-                </a:spcAft>
-                <a:buClrTx/>
-                <a:buSzTx/>
-                <a:buFontTx/>
-                <a:buNone/>
-                <a:tabLst/>
-                <a:defRPr/>
-              </a:pPr>
-              <a:t>1</a:t>
-            </a:fld>
-            <a:endParaRPr kumimoji="0" lang="en-US" sz="1800" b="0" i="0" u="none" strike="noStrike" kern="1200" cap="none" spc="0" normalizeH="0" baseline="0" noProof="0">
-              <a:ln>
-                <a:noFill/>
-              </a:ln>
-              <a:solidFill>
-                <a:prstClr val="black"/>
-              </a:solidFill>
-              <a:effectLst/>
-              <a:uLnTx/>
-              <a:uFillTx/>
-              <a:latin typeface="Aptos" panose="02110004020202020204"/>
-              <a:ea typeface="+mn-ea"/>
-              <a:cs typeface="Arial"/>
-              <a:sym typeface="Arial"/>
-            </a:endParaRPr>
-          </a:p>
-        </p:txBody>
+            <a:r>
+              <a:rPr lang="ko-KR" altLang="en-US" dirty="0"/>
+              <a:t>[약 2분]</a:t>
+            </a:r>
+          </a:p>
+          <a:p>
+            <a:endParaRPr lang="ko-KR" altLang="en-US" dirty="0"/>
+          </a:p>
+          <a:p>
+            <a:r>
+              <a:rPr lang="ko-KR" altLang="en-US" dirty="0"/>
+              <a:t>왼쪽 아홉 가지가 SSA가 정리한 기술·운항 리스크입니다. 전부 설명드리진 않고 우리 선대에서 실제로 걸릴 만한 것만 짚겠습니다.</a:t>
+            </a:r>
+          </a:p>
+          <a:p>
+            <a:endParaRPr lang="ko-KR" altLang="en-US" dirty="0"/>
+          </a:p>
+          <a:p>
+            <a:r>
+              <a:rPr lang="ko-KR" altLang="en-US" dirty="0"/>
+              <a:t>용제성 필터 막힘. 바이오는 용제 성질이 있어서 기존 탱크 벽에 붙어 있던 퇴적물을 떼어냅니다. 그게 필터로 몰려서 막힙니다. 그래서 바이오를 넣기 전에 탱크를 세정하라는 권고가 나옵니다. 전환 초기에 필터를 집중 감시해야 하는 이유이기도 합니다.</a:t>
+            </a:r>
+          </a:p>
+          <a:p>
+            <a:endParaRPr lang="ko-KR" altLang="en-US" dirty="0"/>
+          </a:p>
+          <a:p>
+            <a:r>
+              <a:rPr lang="ko-KR" altLang="en-US" dirty="0"/>
+              <a:t>저온 왁싱. 따뜻한 지역에서 추운 지역으로 갈 때 탱크 안에서 왁스가 생깁니다. 가열 용량이 충분한지 미리 확인해야 합니다. 참고로 유동점 시험이 왁싱을 정확히 예측하지 못할 수 있어서, 필요하면 왁스 출현 온도를 따로 측정하라고 되어 있습니다.</a:t>
+            </a:r>
+          </a:p>
+          <a:p>
+            <a:endParaRPr lang="ko-KR" altLang="en-US" dirty="0"/>
+          </a:p>
+          <a:p>
+            <a:r>
+              <a:rPr lang="ko-KR" altLang="en-US" dirty="0"/>
+              <a:t>씰과 개스킷. FAME의 용제 성질이 고무 재질을 상하게 합니다. 연료 계통의 조인트·씰·개스킷이 바이오와 함께 쓸 수 있는 재질인지 검증이 필요합니다.</a:t>
+            </a:r>
+          </a:p>
+          <a:p>
+            <a:endParaRPr lang="ko-KR" altLang="en-US" dirty="0"/>
+          </a:p>
+          <a:p>
+            <a:r>
+              <a:rPr lang="ko-KR" altLang="en-US" dirty="0"/>
+              <a:t>오른쪽이 실무적으로 가장 유용한 부분입니다. 저장 상태를 볼 때 이 네 가지를 보라는 겁니다. 산화안정성이 가장 직접적인 지표이고, FAME 함량은 에스테르가 분해되면 줄어들고, 산가는 유리지방산이 생기면서 올라가고, 수분은 흡습이나 결로로 늘면서 산화를 가속합니다.</a:t>
+            </a:r>
+          </a:p>
+          <a:p>
+            <a:endParaRPr lang="ko-KR" altLang="en-US" dirty="0"/>
+          </a:p>
+          <a:p>
+            <a:r>
+              <a:rPr lang="ko-KR" altLang="en-US" dirty="0"/>
+              <a:t>운영 원칙은 세 줄로 요약됩니다. 유동점보다 10도 정도 높게 유지하고, 3개월 안에 소모하고, 오래 보관하면 정기적으로 재분석하라.</a:t>
+            </a:r>
+          </a:p>
+          <a:p>
+            <a:endParaRPr lang="ko-KR" altLang="en-US" dirty="0"/>
+          </a:p>
+          <a:p>
+            <a:r>
+              <a:rPr lang="ko-KR" altLang="en-US" dirty="0"/>
+              <a:t>좋은 소식도 있습니다. GCMD가 진행한 Project LOTUS에서 B24를 실제 선박 탱크에 6개월 보관했는데, 산가가 올라가긴 했지만 ISO 8217 한도 안에 머물렀습니다. 별도로 공급망 전체를 5개월 추적한 시험에서도 유의미한 열화가 없었습니다. 즉 관리만 되면 다룰 수 있는 연료라는 뜻입니다.</a:t>
+            </a:r>
+          </a:p>
+          <a:p>
+            <a:endParaRPr lang="ko-KR" altLang="en-US" dirty="0"/>
+          </a:p>
+          <a:p>
+            <a:r>
+              <a:rPr lang="ko-KR" altLang="en-US" dirty="0"/>
+              <a:t>그래서 결론은 'Fresh in, fresh out'입니다. 재고 회전이 최고의 방어책입니다. 여기서 Gard 리포트와 연결되는데, 아라비아만에서 장기 정박 중인 선박은 FAME 블렌드 저장안정성이 떨어질 위험이 크다고 경고했습니다. 우리 선대에 장기 대기 중인 배가 있으면 재고부터 봐야 합니다.</a:t>
+            </a:r>
+          </a:p>
+        </p:txBody>
+      </p:sp>
+      <p:sp>
+        <p:nvSpPr>
+          <p:cNvPr id="4" name="Slide Number Placeholder 3"/>
+          <p:cNvSpPr>
+            <a:spLocks noGrp="1"/>
+          </p:cNvSpPr>
+          <p:nvPr>
+            <p:ph type="sldNum" sz="quarter" idx="5"/>
+          </p:nvPr>
+        </p:nvSpPr>
+        <p:spPr/>
       </p:sp>
     </p:spTree>
-    <p:extLst>
-      <p:ext uri="{BB962C8B-B14F-4D97-AF65-F5344CB8AC3E}">
-        <p14:creationId xmlns:p14="http://schemas.microsoft.com/office/powerpoint/2010/main" val="1024086991"/>
-      </p:ext>
-    </p:extLst>
+  </p:cSld>
+  <p:clrMapOvr>
+    <a:masterClrMapping/>
+  </p:clrMapOvr>
+</p:notes>
+</file>
+
+<file path=ppt/notesSlides/notesSlide11.xml><?xml version="1.0" encoding="utf-8"?>
+<p:notes xmlns:a="http://schemas.openxmlformats.org/drawingml/2006/main" xmlns:r="http://schemas.openxmlformats.org/officeDocument/2006/relationships" xmlns:p="http://schemas.openxmlformats.org/presentationml/2006/main">
+  <p:cSld>
+    <p:spTree>
+      <p:nvGrpSpPr>
+        <p:cNvPr id="1" name=""/>
+        <p:cNvGrpSpPr/>
+        <p:nvPr/>
+      </p:nvGrpSpPr>
+      <p:grpSpPr>
+        <a:xfrm>
+          <a:off x="0" y="0"/>
+          <a:ext cx="0" cy="0"/>
+          <a:chOff x="0" y="0"/>
+          <a:chExt cx="0" cy="0"/>
+        </a:xfrm>
+      </p:grpSpPr>
+      <p:sp>
+        <p:nvSpPr>
+          <p:cNvPr id="2" name="Slide Image Placeholder 1"/>
+          <p:cNvSpPr>
+            <a:spLocks noGrp="1" noRot="1" noChangeAspect="1"/>
+          </p:cNvSpPr>
+          <p:nvPr>
+            <p:ph type="sldImg" idx="2"/>
+          </p:nvPr>
+        </p:nvSpPr>
+        <p:spPr/>
+      </p:sp>
+      <p:sp>
+        <p:nvSpPr>
+          <p:cNvPr id="3" name="Notes Placeholder 2"/>
+          <p:cNvSpPr>
+            <a:spLocks noGrp="1"/>
+          </p:cNvSpPr>
+          <p:nvPr>
+            <p:ph type="body" sz="quarter" idx="3"/>
+          </p:nvPr>
+        </p:nvSpPr>
+        <p:spPr/>
+        <p:txBody>
+          <a:bodyPr/>
+          <a:lstStyle/>
+          <a:p>
+            <a:r>
+              <a:rPr lang="ko-KR" altLang="en-US" dirty="0"/>
+              <a:t>[약 1분 30초 · 빠르게 훑고 지나감]</a:t>
+            </a:r>
+          </a:p>
+          <a:p>
+            <a:endParaRPr lang="ko-KR" altLang="en-US" dirty="0"/>
+          </a:p>
+          <a:p>
+            <a:r>
+              <a:rPr lang="ko-KR" altLang="en-US" dirty="0"/>
+              <a:t>이 슬라이드는 나중에 참고용으로 보시면 되고, 지금은 붉은 줄 두 개만 봐주십시오.</a:t>
+            </a:r>
+          </a:p>
+          <a:p>
+            <a:endParaRPr lang="ko-KR" altLang="en-US" dirty="0"/>
+          </a:p>
+          <a:p>
+            <a:r>
+              <a:rPr lang="ko-KR" altLang="en-US" dirty="0"/>
+              <a:t>IMO 쪽. 지금 시행 중인 건 MEPC.1/Circ.905입니다. 인증받은 바이오연료에 대해 배출 전환계수를 다르게 적용할 수 있게 해주는 임시 지침인데, 조건이 있습니다. 국제 인증 스킴을 통과하고, 화석 MGO 대비 웰투웨이크 기준 최소 65% 감축, 즉 33 gCO2eq/MJ 이하여야 합니다. 인증 스킴은 ISCC와 RSB 두 개입니다. 그리고 지속가능성 증명서(PoS)를 BDN과 함께 받아야 검증이 됩니다.</a:t>
+            </a:r>
+          </a:p>
+          <a:p>
+            <a:endParaRPr lang="ko-KR" altLang="en-US" dirty="0"/>
+          </a:p>
+          <a:p>
+            <a:r>
+              <a:rPr lang="ko-KR" altLang="en-US" dirty="0"/>
+              <a:t>붉은 줄이 2027년 1월 1일부터 적용되는 Circ.905 Rev.1입니다. 두 가지가 바뀝니다. 첫째, 블렌드의 전환계수를 에너지 가중에서 질량 가중으로 바꿉니다. 둘째, 바이오 성분이 인증되지 않았으면 그 블렌드를 화석연료 등가로 취급합니다.</a:t>
+            </a:r>
+          </a:p>
+          <a:p>
+            <a:endParaRPr lang="ko-KR" altLang="en-US" dirty="0"/>
+          </a:p>
+          <a:p>
+            <a:r>
+              <a:rPr lang="ko-KR" altLang="en-US" dirty="0"/>
+              <a:t>이게 왜 중요하냐면, 계산 방식이 바뀌면 CII 등급이 바뀝니다. 그리고 인증 서류를 못 챙긴 스템은 바이오를 넣고도 아무 혜택을 못 받게 됩니다. 실무적으로는 SEEMP Part II와 Part III, DCS 보고 체계를 손봐야 한다는 뜻입니다.</a:t>
+            </a:r>
+          </a:p>
+          <a:p>
+            <a:endParaRPr lang="ko-KR" altLang="en-US" dirty="0"/>
+          </a:p>
+          <a:p>
+            <a:r>
+              <a:rPr lang="ko-KR" altLang="en-US" dirty="0"/>
+              <a:t>EU 쪽은 이미 돌아가고 있습니다. FuelEU가 2025년부터 2% 감축이고 2030년 6%, 2050년 80%까지 갑니다. EU ETS는 올해부터 메탄과 아산화질소가 들어왔고, 올해 배출분은 내년에 100% 제출해야 합니다.</a:t>
+            </a:r>
+          </a:p>
+          <a:p>
+            <a:endParaRPr lang="ko-KR" altLang="en-US" dirty="0"/>
+          </a:p>
+          <a:p>
+            <a:r>
+              <a:rPr lang="ko-KR" altLang="en-US" dirty="0"/>
+              <a:t>RED III 기준을 못 넘는 바이오나 식량작물 원료 바이오는 화석 등가로 처리된다는 점도 IMO와 같습니다. 인증이 곧 가치입니다.</a:t>
+            </a:r>
+          </a:p>
+          <a:p>
+            <a:endParaRPr lang="ko-KR" altLang="en-US" dirty="0"/>
+          </a:p>
+          <a:p>
+            <a:r>
+              <a:rPr lang="ko-KR" altLang="en-US" dirty="0"/>
+              <a:t>아래 박스는 실수하기 쉬운 부분입니다. EU ETS는 배 위에서 나온 배출만 보는 톤당 기준이고, FuelEU는 생산부터 연소까지 전 주기를 보는 MJ당 집약도입니다. 계수가 다르니 섞어 쓰면 안 됩니다.</a:t>
+            </a:r>
+          </a:p>
+        </p:txBody>
+      </p:sp>
+      <p:sp>
+        <p:nvSpPr>
+          <p:cNvPr id="4" name="Slide Number Placeholder 3"/>
+          <p:cNvSpPr>
+            <a:spLocks noGrp="1"/>
+          </p:cNvSpPr>
+          <p:nvPr>
+            <p:ph type="sldNum" sz="quarter" idx="5"/>
+          </p:nvPr>
+        </p:nvSpPr>
+        <p:spPr/>
+      </p:sp>
+    </p:spTree>
+  </p:cSld>
+  <p:clrMapOvr>
+    <a:masterClrMapping/>
+  </p:clrMapOvr>
+</p:notes>
+</file>
+
+<file path=ppt/notesSlides/notesSlide12.xml><?xml version="1.0" encoding="utf-8"?>
+<p:notes xmlns:a="http://schemas.openxmlformats.org/drawingml/2006/main" xmlns:r="http://schemas.openxmlformats.org/officeDocument/2006/relationships" xmlns:p="http://schemas.openxmlformats.org/presentationml/2006/main">
+  <p:cSld>
+    <p:spTree>
+      <p:nvGrpSpPr>
+        <p:cNvPr id="1" name=""/>
+        <p:cNvGrpSpPr/>
+        <p:nvPr/>
+      </p:nvGrpSpPr>
+      <p:grpSpPr>
+        <a:xfrm>
+          <a:off x="0" y="0"/>
+          <a:ext cx="0" cy="0"/>
+          <a:chOff x="0" y="0"/>
+          <a:chExt cx="0" cy="0"/>
+        </a:xfrm>
+      </p:grpSpPr>
+      <p:sp>
+        <p:nvSpPr>
+          <p:cNvPr id="2" name="Slide Image Placeholder 1"/>
+          <p:cNvSpPr>
+            <a:spLocks noGrp="1" noRot="1" noChangeAspect="1"/>
+          </p:cNvSpPr>
+          <p:nvPr>
+            <p:ph type="sldImg" idx="2"/>
+          </p:nvPr>
+        </p:nvSpPr>
+        <p:spPr/>
+      </p:sp>
+      <p:sp>
+        <p:nvSpPr>
+          <p:cNvPr id="3" name="Notes Placeholder 2"/>
+          <p:cNvSpPr>
+            <a:spLocks noGrp="1"/>
+          </p:cNvSpPr>
+          <p:nvPr>
+            <p:ph type="body" sz="quarter" idx="3"/>
+          </p:nvPr>
+        </p:nvSpPr>
+        <p:spPr/>
+        <p:txBody>
+          <a:bodyPr/>
+          <a:lstStyle/>
+          <a:p>
+            <a:r>
+              <a:rPr lang="ko-KR" altLang="en-US" dirty="0"/>
+              <a:t>[약 1분 30초]</a:t>
+            </a:r>
+          </a:p>
+          <a:p>
+            <a:endParaRPr lang="ko-KR" altLang="en-US" dirty="0"/>
+          </a:p>
+          <a:p>
+            <a:r>
+              <a:rPr lang="ko-KR" altLang="en-US" dirty="0"/>
+              <a:t>왼쪽은 어떤 표준을 같이 봐야 하느냐입니다. ISO 8217:2024가 기본인데, 바이오 블렌드는 그것만으로 부족해서 싱가포르 TR 140:2025가 추가 파라미터를 보완합니다. 여기에 요오드가, 즉 불포화도를 같이 보라고 권고합니다. 이중결합이 많으면 산화가 빨라지고 중합해서 검이나 침전물이 생기면서 필터와 인젝터를 막습니다. 저장 안정성과 직결됩니다.</a:t>
+            </a:r>
+          </a:p>
+          <a:p>
+            <a:endParaRPr lang="ko-KR" altLang="en-US" dirty="0"/>
+          </a:p>
+          <a:p>
+            <a:r>
+              <a:rPr lang="ko-KR" altLang="en-US" dirty="0"/>
+              <a:t>작은 오해 하나 정리하고 가겠습니다. B30이 FAME 30%가 아닙니다. B 뒤 숫자는 바이오 성분의 부피 비율이고, EN 14214를 준수하는 B100의 FAME가 최소 96.5%이니까 B30의 실제 FAME는 28.95%입니다. 계산할 때 헷갈리기 쉽습니다.</a:t>
+            </a:r>
+          </a:p>
+          <a:p>
+            <a:endParaRPr lang="ko-KR" altLang="en-US" dirty="0"/>
+          </a:p>
+          <a:p>
+            <a:r>
+              <a:rPr lang="ko-KR" altLang="en-US" dirty="0"/>
+              <a:t>오른쪽이 중요합니다. EN 14214가 유일한 정답은 아닙니다. FAME 생산이 항공 SAF와 원료를 두고 경쟁하기 때문에 마린 수요를 감당하기 어려울 거라는 게 업계 전망이고, 그래서 이미 HVO, 오프스펙 FAME, 업그레이드 열분해유, 바이오 난방유, 그리고 CNSL 같은 제품이 유통되고 있습니다. 실제로 좋은 피드백을 받은 사례도 있습니다.</a:t>
+            </a:r>
+          </a:p>
+          <a:p>
+            <a:endParaRPr lang="ko-KR" altLang="en-US" dirty="0"/>
+          </a:p>
+          <a:p>
+            <a:r>
+              <a:rPr lang="ko-KR" altLang="en-US" dirty="0"/>
+              <a:t>그런데 조건이 붙습니다. 오른쪽 6단계 검증을 전부 거쳐야 하고, 매도인과 매수인이 합의해야 하며, 기국과 선급 승인이 필요합니다. 문서 심사부터 시작해서 성분 분석, 사전 적합성 평가, 해상 시운전 데이터, 최종 성능 평가, 그리고 기관 내구성 중장기 평가까지입니다.</a:t>
+            </a:r>
+          </a:p>
+          <a:p>
+            <a:endParaRPr lang="ko-KR" altLang="en-US" dirty="0"/>
+          </a:p>
+          <a:p>
+            <a:r>
+              <a:rPr lang="ko-KR" altLang="en-US" dirty="0"/>
+              <a:t>여기에 OEM 확인서, 즉 LONO를 받아두는 게 전제입니다. 엔진 제작사에서 어떤 블렌드를 쓸 수 있는지 명시적으로 받아야 하고, 못 받으면 선급이 설비 상태를 보고 판단하게 됩니다.</a:t>
+            </a:r>
+          </a:p>
+          <a:p>
+            <a:endParaRPr lang="ko-KR" altLang="en-US" dirty="0"/>
+          </a:p>
+          <a:p>
+            <a:r>
+              <a:rPr lang="ko-KR" altLang="en-US" dirty="0"/>
+              <a:t>앞서 본 Case 3이 정확히 이 게이트를 다 거쳤는지 확인이 안 되는 상태에서 벌어진 일입니다.</a:t>
+            </a:r>
+          </a:p>
+        </p:txBody>
+      </p:sp>
+      <p:sp>
+        <p:nvSpPr>
+          <p:cNvPr id="4" name="Slide Number Placeholder 3"/>
+          <p:cNvSpPr>
+            <a:spLocks noGrp="1"/>
+          </p:cNvSpPr>
+          <p:nvPr>
+            <p:ph type="sldNum" sz="quarter" idx="5"/>
+          </p:nvPr>
+        </p:nvSpPr>
+        <p:spPr/>
+      </p:sp>
+    </p:spTree>
+  </p:cSld>
+  <p:clrMapOvr>
+    <a:masterClrMapping/>
+  </p:clrMapOvr>
+</p:notes>
+</file>
+
+<file path=ppt/notesSlides/notesSlide13.xml><?xml version="1.0" encoding="utf-8"?>
+<p:notes xmlns:a="http://schemas.openxmlformats.org/drawingml/2006/main" xmlns:r="http://schemas.openxmlformats.org/officeDocument/2006/relationships" xmlns:p="http://schemas.openxmlformats.org/presentationml/2006/main">
+  <p:cSld>
+    <p:spTree>
+      <p:nvGrpSpPr>
+        <p:cNvPr id="1" name=""/>
+        <p:cNvGrpSpPr/>
+        <p:nvPr/>
+      </p:nvGrpSpPr>
+      <p:grpSpPr>
+        <a:xfrm>
+          <a:off x="0" y="0"/>
+          <a:ext cx="0" cy="0"/>
+          <a:chOff x="0" y="0"/>
+          <a:chExt cx="0" cy="0"/>
+        </a:xfrm>
+      </p:grpSpPr>
+      <p:sp>
+        <p:nvSpPr>
+          <p:cNvPr id="2" name="Slide Image Placeholder 1"/>
+          <p:cNvSpPr>
+            <a:spLocks noGrp="1" noRot="1" noChangeAspect="1"/>
+          </p:cNvSpPr>
+          <p:nvPr>
+            <p:ph type="sldImg" idx="2"/>
+          </p:nvPr>
+        </p:nvSpPr>
+        <p:spPr/>
+      </p:sp>
+      <p:sp>
+        <p:nvSpPr>
+          <p:cNvPr id="3" name="Notes Placeholder 2"/>
+          <p:cNvSpPr>
+            <a:spLocks noGrp="1"/>
+          </p:cNvSpPr>
+          <p:nvPr>
+            <p:ph type="body" sz="quarter" idx="3"/>
+          </p:nvPr>
+        </p:nvSpPr>
+        <p:spPr/>
+        <p:txBody>
+          <a:bodyPr/>
+          <a:lstStyle/>
+          <a:p>
+            <a:r>
+              <a:rPr lang="ko-KR" altLang="en-US" dirty="0"/>
+              <a:t>[약 3분 · 오늘의 핵심 슬라이드. 여기서 충분히 시간을 쓸 것]</a:t>
+            </a:r>
+          </a:p>
+          <a:p>
+            <a:endParaRPr lang="ko-KR" altLang="en-US" dirty="0"/>
+          </a:p>
+          <a:p>
+            <a:r>
+              <a:rPr lang="ko-KR" altLang="en-US" dirty="0"/>
+              <a:t>지금까지 내용을 한 장으로 모았습니다. 두 문서가 만나는 지점이 다섯 개입니다.</a:t>
+            </a:r>
+          </a:p>
+          <a:p>
+            <a:endParaRPr lang="ko-KR" altLang="en-US" dirty="0"/>
+          </a:p>
+          <a:p>
+            <a:r>
+              <a:rPr lang="ko-KR" altLang="en-US" dirty="0"/>
+              <a:t>첫째, 규격 준수가 곧 사용 적합성이 아니라는 점. Gard는 온스펙 연료의 40%가 문제를 일으켰다고 하고, SSA는 ISO 8217만으로 부족하니 TR 140의 추가 파라미터와 요오드가를 같이 보라고 합니다. 접근은 다르지만 결론은 같습니다. 우리 구매 스펙에 'ISO 8217 준수' 한 줄만 있다면 그건 바꿔야 합니다.</a:t>
+            </a:r>
+          </a:p>
+          <a:p>
+            <a:endParaRPr lang="ko-KR" altLang="en-US" dirty="0"/>
+          </a:p>
+          <a:p>
+            <a:r>
+              <a:rPr lang="ko-KR" altLang="en-US" dirty="0"/>
+              <a:t>둘째, CNSL과 non-FAME이 두 문서를 직접 연결합니다. Gard 사례 3에서 실제로 주기관이 섰고, SSA는 같은 물질을 허용 가능한 대안으로 소개하되 6단계 검증을 전제로 답니다. 우리 회사가 이걸 받을 건지 말 건지, 받는다면 어떤 조건인지 명시적으로 정해야 합니다.</a:t>
+            </a:r>
+          </a:p>
+          <a:p>
+            <a:endParaRPr lang="ko-KR" altLang="en-US" dirty="0"/>
+          </a:p>
+          <a:p>
+            <a:r>
+              <a:rPr lang="ko-KR" altLang="en-US" dirty="0"/>
+              <a:t>셋째, 저장 안정성. Gard는 아라비아만에서 장기 정박한 선박의 FAME 블렌드를 경고하고, SSA는 3개월 내 사용과 4대 지표 모니터링을 권고합니다. 이건 계약 문제가 아니라 우리 내부 절차 문제입니다. 탱크 재고 선입선출 규정과 재분석 주기를 만들면 해결됩니다.</a:t>
+            </a:r>
+          </a:p>
+          <a:p>
+            <a:endParaRPr lang="ko-KR" altLang="en-US" dirty="0"/>
+          </a:p>
+          <a:p>
+            <a:r>
+              <a:rPr lang="ko-KR" altLang="en-US" dirty="0"/>
+              <a:t>넷째, 샘플과 문서. Gard는 어떤 샘플이 구속력을 갖느냐를 얘기하고, SSA는 BDN과 PoS 얘기를 합니다. 그런데 PoS는 인도 즉시 안 나옵니다. 공급자가 수량 배분을 계산해야 해서 보통 30일 정도 걸리고, 한 번의 인도에 여러 장의 PoS가 나올 수도 있습니다. 이걸 모르면 보고 마감을 못 맞춥니다. 결국 둘 다 계약 체결 단계에서 함께 설계해야 하는 항목입니다.</a:t>
+            </a:r>
+          </a:p>
+          <a:p>
+            <a:endParaRPr lang="ko-KR" altLang="en-US" dirty="0"/>
+          </a:p>
+          <a:p>
+            <a:r>
+              <a:rPr lang="ko-KR" altLang="en-US" dirty="0"/>
+              <a:t>다섯째, 규제 위반은 즉시 운항 정지로 이어진다는 점. Gard는 황분과 인화점, SSA는 NOx와 캐리지 제한과 Circ.905를 다룹니다. 부서별로 흩어져 있는데 하나의 캘린더로 합쳐야 관리가 됩니다.</a:t>
+            </a:r>
+          </a:p>
+          <a:p>
+            <a:endParaRPr lang="ko-KR" altLang="en-US" dirty="0"/>
+          </a:p>
+          <a:p>
+            <a:r>
+              <a:rPr lang="ko-KR" altLang="en-US" dirty="0"/>
+              <a:t>한 문장으로 줄이면 아래 박스입니다. '스펙은 통과했는데 배가 섰다.' 그리고 바이오 전환이 그 리스크를 한 단계 더 키우고 있습니다.</a:t>
+            </a:r>
+          </a:p>
+        </p:txBody>
+      </p:sp>
+      <p:sp>
+        <p:nvSpPr>
+          <p:cNvPr id="4" name="Slide Number Placeholder 3"/>
+          <p:cNvSpPr>
+            <a:spLocks noGrp="1"/>
+          </p:cNvSpPr>
+          <p:nvPr>
+            <p:ph type="sldNum" sz="quarter" idx="5"/>
+          </p:nvPr>
+        </p:nvSpPr>
+        <p:spPr/>
+      </p:sp>
+    </p:spTree>
+  </p:cSld>
+  <p:clrMapOvr>
+    <a:masterClrMapping/>
+  </p:clrMapOvr>
+</p:notes>
+</file>
+
+<file path=ppt/notesSlides/notesSlide14.xml><?xml version="1.0" encoding="utf-8"?>
+<p:notes xmlns:a="http://schemas.openxmlformats.org/drawingml/2006/main" xmlns:r="http://schemas.openxmlformats.org/officeDocument/2006/relationships" xmlns:p="http://schemas.openxmlformats.org/presentationml/2006/main">
+  <p:cSld>
+    <p:spTree>
+      <p:nvGrpSpPr>
+        <p:cNvPr id="1" name=""/>
+        <p:cNvGrpSpPr/>
+        <p:nvPr/>
+      </p:nvGrpSpPr>
+      <p:grpSpPr>
+        <a:xfrm>
+          <a:off x="0" y="0"/>
+          <a:ext cx="0" cy="0"/>
+          <a:chOff x="0" y="0"/>
+          <a:chExt cx="0" cy="0"/>
+        </a:xfrm>
+      </p:grpSpPr>
+      <p:sp>
+        <p:nvSpPr>
+          <p:cNvPr id="2" name="Slide Image Placeholder 1"/>
+          <p:cNvSpPr>
+            <a:spLocks noGrp="1" noRot="1" noChangeAspect="1"/>
+          </p:cNvSpPr>
+          <p:nvPr>
+            <p:ph type="sldImg" idx="2"/>
+          </p:nvPr>
+        </p:nvSpPr>
+        <p:spPr/>
+      </p:sp>
+      <p:sp>
+        <p:nvSpPr>
+          <p:cNvPr id="3" name="Notes Placeholder 2"/>
+          <p:cNvSpPr>
+            <a:spLocks noGrp="1"/>
+          </p:cNvSpPr>
+          <p:nvPr>
+            <p:ph type="body" sz="quarter" idx="3"/>
+          </p:nvPr>
+        </p:nvSpPr>
+        <p:spPr/>
+        <p:txBody>
+          <a:bodyPr/>
+          <a:lstStyle/>
+          <a:p>
+            <a:r>
+              <a:rPr lang="ko-KR" altLang="en-US" dirty="0"/>
+              <a:t>[약 2분]</a:t>
+            </a:r>
+          </a:p>
+          <a:p>
+            <a:endParaRPr lang="ko-KR" altLang="en-US" dirty="0"/>
+          </a:p>
+          <a:p>
+            <a:r>
+              <a:rPr lang="ko-KR" altLang="en-US" dirty="0"/>
+              <a:t>교집합에서 나온 다섯 가지를 시간 순으로 배치했습니다.</a:t>
+            </a:r>
+          </a:p>
+          <a:p>
+            <a:endParaRPr lang="ko-KR" altLang="en-US" dirty="0"/>
+          </a:p>
+          <a:p>
+            <a:r>
+              <a:rPr lang="ko-KR" altLang="en-US" dirty="0"/>
+              <a:t>Now, 한 달 안에 할 것들입니다.</a:t>
+            </a:r>
+          </a:p>
+          <a:p>
+            <a:endParaRPr lang="ko-KR" altLang="en-US" dirty="0"/>
+          </a:p>
+          <a:p>
+            <a:r>
+              <a:rPr lang="ko-KR" altLang="en-US" dirty="0"/>
+              <a:t>구매 스펙에 Clause 5와 fingerprinting을 명문화합니다. 문구만 넣으면 되는 일이라 비용이 거의 안 듭니다.</a:t>
+            </a:r>
+          </a:p>
+          <a:p>
+            <a:endParaRPr lang="ko-KR" altLang="en-US" dirty="0"/>
+          </a:p>
+          <a:p>
+            <a:r>
+              <a:rPr lang="ko-KR" altLang="en-US" dirty="0"/>
+              <a:t>매니폴드 샘플을 구속력 있는 샘플로 협상합니다. 이건 공급자와 협의가 필요해서 시간이 걸리지만, 지금 시작해야 합니다.</a:t>
+            </a:r>
+          </a:p>
+          <a:p>
+            <a:endParaRPr lang="ko-KR" altLang="en-US" dirty="0"/>
+          </a:p>
+          <a:p>
+            <a:r>
+              <a:rPr lang="ko-KR" altLang="en-US" dirty="0"/>
+              <a:t>선내 벙커 관리 지침을 배포합니다. Gard가 지적한 게, 선원들이 육상의 구체적 지침 없이 개인 경험으로 대응하고 있다는 겁니다. 감시할 기계 파라미터와 성능 저하의 조기 신호를 정리해서 내려보내는 것만으로도 효과가 큽니다.</a:t>
+            </a:r>
+          </a:p>
+          <a:p>
+            <a:endParaRPr lang="ko-KR" altLang="en-US" dirty="0"/>
+          </a:p>
+          <a:p>
+            <a:r>
+              <a:rPr lang="ko-KR" altLang="en-US" dirty="0"/>
+              <a:t>장기 정박 중인 선박의 바이오 블렌드 재고를 점검합니다. 이건 이번 주에라도 가능합니다.</a:t>
+            </a:r>
+          </a:p>
+          <a:p>
+            <a:endParaRPr lang="ko-KR" altLang="en-US" dirty="0"/>
+          </a:p>
+          <a:p>
+            <a:r>
+              <a:rPr lang="ko-KR" altLang="en-US" dirty="0"/>
+              <a:t>Next, 1~3개월입니다. 바이오 탱크 선입선출 규정과 정기 재분석 주기를 만들고, OEM LONO와 선급 제출 서류를 정비하고, PoS 30일 리드타임을 반영해서 보고 프로세스를 조정합니다.</a:t>
+            </a:r>
+          </a:p>
+          <a:p>
+            <a:endParaRPr lang="ko-KR" altLang="en-US" dirty="0"/>
+          </a:p>
+          <a:p>
+            <a:r>
+              <a:rPr lang="ko-KR" altLang="en-US" dirty="0"/>
+              <a:t>Later, 3~12개월입니다. Circ.905 Rev.1에 맞춰 DCS와 SEEMP Part II·III를 개정해야 하는데 2027년 1월 발효라 지금 시작하면 여유가 있습니다. non-FAME 정책을 확정해서 문서화하고, 용선·공급계약 표준안을 개정하고, 선원 교육 모듈에 바이오 운영 절차를 넣습니다.</a:t>
+            </a:r>
+          </a:p>
+          <a:p>
+            <a:endParaRPr lang="ko-KR" altLang="en-US" dirty="0"/>
+          </a:p>
+          <a:p>
+            <a:r>
+              <a:rPr lang="ko-KR" altLang="en-US" dirty="0"/>
+              <a:t>오른쪽 박스를 다시 강조드리면, 선원이 개인 경험에 의존하고 있다는 게 Gard가 짚은 가장 현실적인 공백입니다. 그리고 이건 우리가 가장 빨리, 가장 싸게 메울 수 있는 항목이기도 합니다.</a:t>
+            </a:r>
+          </a:p>
+        </p:txBody>
+      </p:sp>
+      <p:sp>
+        <p:nvSpPr>
+          <p:cNvPr id="4" name="Slide Number Placeholder 3"/>
+          <p:cNvSpPr>
+            <a:spLocks noGrp="1"/>
+          </p:cNvSpPr>
+          <p:nvPr>
+            <p:ph type="sldNum" sz="quarter" idx="5"/>
+          </p:nvPr>
+        </p:nvSpPr>
+        <p:spPr/>
+      </p:sp>
+    </p:spTree>
+  </p:cSld>
+  <p:clrMapOvr>
+    <a:masterClrMapping/>
+  </p:clrMapOvr>
+</p:notes>
+</file>
+
+<file path=ppt/notesSlides/notesSlide15.xml><?xml version="1.0" encoding="utf-8"?>
+<p:notes xmlns:a="http://schemas.openxmlformats.org/drawingml/2006/main" xmlns:r="http://schemas.openxmlformats.org/officeDocument/2006/relationships" xmlns:p="http://schemas.openxmlformats.org/presentationml/2006/main">
+  <p:cSld>
+    <p:spTree>
+      <p:nvGrpSpPr>
+        <p:cNvPr id="1" name=""/>
+        <p:cNvGrpSpPr/>
+        <p:nvPr/>
+      </p:nvGrpSpPr>
+      <p:grpSpPr>
+        <a:xfrm>
+          <a:off x="0" y="0"/>
+          <a:ext cx="0" cy="0"/>
+          <a:chOff x="0" y="0"/>
+          <a:chExt cx="0" cy="0"/>
+        </a:xfrm>
+      </p:grpSpPr>
+      <p:sp>
+        <p:nvSpPr>
+          <p:cNvPr id="2" name="Slide Image Placeholder 1"/>
+          <p:cNvSpPr>
+            <a:spLocks noGrp="1" noRot="1" noChangeAspect="1"/>
+          </p:cNvSpPr>
+          <p:nvPr>
+            <p:ph type="sldImg" idx="2"/>
+          </p:nvPr>
+        </p:nvSpPr>
+        <p:spPr/>
+      </p:sp>
+      <p:sp>
+        <p:nvSpPr>
+          <p:cNvPr id="3" name="Notes Placeholder 2"/>
+          <p:cNvSpPr>
+            <a:spLocks noGrp="1"/>
+          </p:cNvSpPr>
+          <p:nvPr>
+            <p:ph type="body" sz="quarter" idx="3"/>
+          </p:nvPr>
+        </p:nvSpPr>
+        <p:spPr/>
+        <p:txBody>
+          <a:bodyPr/>
+          <a:lstStyle/>
+          <a:p>
+            <a:r>
+              <a:rPr lang="ko-KR" altLang="en-US" dirty="0"/>
+              <a:t>[약 2분 · 마무리 및 논의]</a:t>
+            </a:r>
+          </a:p>
+          <a:p>
+            <a:endParaRPr lang="ko-KR" altLang="en-US" dirty="0"/>
+          </a:p>
+          <a:p>
+            <a:r>
+              <a:rPr lang="ko-KR" altLang="en-US" dirty="0"/>
+              <a:t>결정을 부탁드릴 사항 세 가지입니다.</a:t>
+            </a:r>
+          </a:p>
+          <a:p>
+            <a:endParaRPr lang="ko-KR" altLang="en-US" dirty="0"/>
+          </a:p>
+          <a:p>
+            <a:r>
+              <a:rPr lang="ko-KR" altLang="en-US" dirty="0"/>
+              <a:t>첫째, non-FAME 수용 여부입니다. 선택지는 세 가지입니다. 전면 금지하거나, 6단계 검증을 통과한 경우에만 조건부로 허용하거나, 건별로 승인하는 방식입니다. 저는 조건부 허용이 현실적이라고 봅니다. 전면 금지는 FAME 공급 제약을 감안하면 지속 가능하지 않고, 건별 승인은 기준이 없어서 결국 아무나 통과하게 됩니다. 다만 Gard 사례 3에서 실제 주기관 손상이 났으니, 조건부로 가더라도 기준은 문서로 못박아야 합니다.</a:t>
+            </a:r>
+          </a:p>
+          <a:p>
+            <a:endParaRPr lang="ko-KR" altLang="en-US" dirty="0"/>
+          </a:p>
+          <a:p>
+            <a:r>
+              <a:rPr lang="ko-KR" altLang="en-US" dirty="0"/>
+              <a:t>둘째, 계약 조항 개정 착수 승인입니다. 매니폴드 샘플을 구속력 있는 샘플로, fingerprinting과 공동시험 프로토콜을 표준 조항으로 넣는 작업입니다. 법무와 구매 쪽 리소스 배정이 필요합니다.</a:t>
+            </a:r>
+          </a:p>
+          <a:p>
+            <a:endParaRPr lang="ko-KR" altLang="en-US" dirty="0"/>
+          </a:p>
+          <a:p>
+            <a:r>
+              <a:rPr lang="ko-KR" altLang="en-US" dirty="0"/>
+              <a:t>셋째, Circ.905 Rev.1 대응 오너십입니다. 전환계수 질량가중 변경과 '비인증 바이오는 화석 등가' 조항이 CII 등급에 직접 영향을 줍니다. 어느 부서가 주관하고 언제 시작할지 정해주셔야 합니다.</a:t>
+            </a:r>
+          </a:p>
+          <a:p>
+            <a:endParaRPr lang="ko-KR" altLang="en-US" dirty="0"/>
+          </a:p>
+          <a:p>
+            <a:r>
+              <a:rPr lang="ko-KR" altLang="en-US" dirty="0"/>
+              <a:t>마지막으로 Gard 리포트가 결론에서 강조한 문장을 그대로 옮겼습니다. 불량 벙커의 공급과 사용을 막는 건 선주와 용선자의 공동 책임이고, 그게 선박 안전과 운항 연속성을 지키는 가장 효과적인 방법이라는 겁니다. 우리 쪽에서만 조이는 게 아니라 상대방과 같이 설계해야 한다는 뜻으로 이해하고 있습니다.</a:t>
+            </a:r>
+          </a:p>
+          <a:p>
+            <a:endParaRPr lang="ko-KR" altLang="en-US" dirty="0"/>
+          </a:p>
+          <a:p>
+            <a:r>
+              <a:rPr lang="ko-KR" altLang="en-US" dirty="0"/>
+              <a:t>질문 받겠습니다.</a:t>
+            </a:r>
+          </a:p>
+        </p:txBody>
+      </p:sp>
+      <p:sp>
+        <p:nvSpPr>
+          <p:cNvPr id="4" name="Slide Number Placeholder 3"/>
+          <p:cNvSpPr>
+            <a:spLocks noGrp="1"/>
+          </p:cNvSpPr>
+          <p:nvPr>
+            <p:ph type="sldNum" sz="quarter" idx="5"/>
+          </p:nvPr>
+        </p:nvSpPr>
+        <p:spPr/>
+      </p:sp>
+    </p:spTree>
+  </p:cSld>
+  <p:clrMapOvr>
+    <a:masterClrMapping/>
+  </p:clrMapOvr>
+</p:notes>
+</file>
+
+<file path=ppt/notesSlides/notesSlide2.xml><?xml version="1.0" encoding="utf-8"?>
+<p:notes xmlns:a="http://schemas.openxmlformats.org/drawingml/2006/main" xmlns:r="http://schemas.openxmlformats.org/officeDocument/2006/relationships" xmlns:p="http://schemas.openxmlformats.org/presentationml/2006/main">
+  <p:cSld>
+    <p:spTree>
+      <p:nvGrpSpPr>
+        <p:cNvPr id="1" name=""/>
+        <p:cNvGrpSpPr/>
+        <p:nvPr/>
+      </p:nvGrpSpPr>
+      <p:grpSpPr>
+        <a:xfrm>
+          <a:off x="0" y="0"/>
+          <a:ext cx="0" cy="0"/>
+          <a:chOff x="0" y="0"/>
+          <a:chExt cx="0" cy="0"/>
+        </a:xfrm>
+      </p:grpSpPr>
+      <p:sp>
+        <p:nvSpPr>
+          <p:cNvPr id="2" name="Slide Image Placeholder 1"/>
+          <p:cNvSpPr>
+            <a:spLocks noGrp="1" noRot="1" noChangeAspect="1"/>
+          </p:cNvSpPr>
+          <p:nvPr>
+            <p:ph type="sldImg" idx="2"/>
+          </p:nvPr>
+        </p:nvSpPr>
+        <p:spPr/>
+      </p:sp>
+      <p:sp>
+        <p:nvSpPr>
+          <p:cNvPr id="3" name="Notes Placeholder 2"/>
+          <p:cNvSpPr>
+            <a:spLocks noGrp="1"/>
+          </p:cNvSpPr>
+          <p:nvPr>
+            <p:ph type="body" sz="quarter" idx="3"/>
+          </p:nvPr>
+        </p:nvSpPr>
+        <p:spPr/>
+        <p:txBody>
+          <a:bodyPr/>
+          <a:lstStyle/>
+          <a:p>
+            <a:r>
+              <a:rPr lang="ko-KR" altLang="en-US" dirty="0"/>
+              <a:t>[약 2분 · 여기서 결론을 먼저 말하고 시작]</a:t>
+            </a:r>
+          </a:p>
+          <a:p>
+            <a:endParaRPr lang="ko-KR" altLang="en-US" dirty="0"/>
+          </a:p>
+          <a:p>
+            <a:r>
+              <a:rPr lang="ko-KR" altLang="en-US" dirty="0"/>
+              <a:t>숫자 네 개만 기억하시면 됩니다.</a:t>
+            </a:r>
+          </a:p>
+          <a:p>
+            <a:endParaRPr lang="ko-KR" altLang="en-US" dirty="0"/>
+          </a:p>
+          <a:p>
+            <a:r>
+              <a:rPr lang="ko-KR" altLang="en-US" dirty="0"/>
+              <a:t>+50%. Gard가 올해 1월부터 5월까지 접수한 벙커 관련 클레임이 약 70건인데, 작년 같은 기간보다 50% 늘었습니다.</a:t>
+            </a:r>
+          </a:p>
+          <a:p>
+            <a:endParaRPr lang="ko-KR" altLang="en-US" dirty="0"/>
+          </a:p>
+          <a:p>
+            <a:r>
+              <a:rPr lang="ko-KR" altLang="en-US" dirty="0"/>
+              <a:t>85%. 그중 VLSFO가 85% 이상입니다. 2020년 황산화물 규제 이후 주력 연료이기도 하고, 여러 성분을 섞어 만들기 때문에 조성 편차와 이상 화학물질 위험이 구조적으로 큽니다.</a:t>
+            </a:r>
+          </a:p>
+          <a:p>
+            <a:endParaRPr lang="ko-KR" altLang="en-US" dirty="0"/>
+          </a:p>
+          <a:p>
+            <a:r>
+              <a:rPr lang="ko-KR" altLang="en-US" dirty="0"/>
+              <a:t>40%. 이게 오늘 가장 중요한 숫자입니다. 클레임의 40%는 ISO 8217 Table 2를 전부 통과한 연료에서 나왔습니다. 시험 성적서상으로는 합격인데 배가 섰다는 뜻입니다.</a:t>
+            </a:r>
+          </a:p>
+          <a:p>
+            <a:endParaRPr lang="ko-KR" altLang="en-US" dirty="0"/>
+          </a:p>
+          <a:p>
+            <a:r>
+              <a:rPr lang="ko-KR" altLang="en-US" dirty="0"/>
+              <a:t>+53%. 싱가포르 바이오 블렌드 판매가 1년 만에 53% 늘었습니다.</a:t>
+            </a:r>
+          </a:p>
+          <a:p>
+            <a:endParaRPr lang="ko-KR" altLang="en-US" dirty="0"/>
+          </a:p>
+          <a:p>
+            <a:r>
+              <a:rPr lang="ko-KR" altLang="en-US" dirty="0"/>
+              <a:t>왼쪽은 왜 늘었는가입니다. 2월 말 중동 분쟁 이후 정제사들이 원유 구성을 바꾸고 감산했고, 그 결과 총침전물과 캣파인 오프스펙이 전 세계적으로 늘었습니다. VPS도 같은 기간 11개 지역에 20건의 경보를 냈습니다.</a:t>
+            </a:r>
+          </a:p>
+          <a:p>
+            <a:endParaRPr lang="ko-KR" altLang="en-US" dirty="0"/>
+          </a:p>
+          <a:p>
+            <a:r>
+              <a:rPr lang="ko-KR" altLang="en-US" dirty="0"/>
+              <a:t>오른쪽 세 가지는 마지막 슬라이드에서 다시 말씀드릴 결정 사항입니다. 지금은 '이런 게 나온다' 정도만 봐주시면 됩니다.</a:t>
+            </a:r>
+          </a:p>
+        </p:txBody>
+      </p:sp>
+      <p:sp>
+        <p:nvSpPr>
+          <p:cNvPr id="4" name="Slide Number Placeholder 3"/>
+          <p:cNvSpPr>
+            <a:spLocks noGrp="1"/>
+          </p:cNvSpPr>
+          <p:nvPr>
+            <p:ph type="sldNum" sz="quarter" idx="5"/>
+          </p:nvPr>
+        </p:nvSpPr>
+        <p:spPr/>
+      </p:sp>
+    </p:spTree>
+  </p:cSld>
+  <p:clrMapOvr>
+    <a:masterClrMapping/>
+  </p:clrMapOvr>
+</p:notes>
+</file>
+
+<file path=ppt/notesSlides/notesSlide3.xml><?xml version="1.0" encoding="utf-8"?>
+<p:notes xmlns:a="http://schemas.openxmlformats.org/drawingml/2006/main" xmlns:r="http://schemas.openxmlformats.org/officeDocument/2006/relationships" xmlns:p="http://schemas.openxmlformats.org/presentationml/2006/main">
+  <p:cSld>
+    <p:spTree>
+      <p:nvGrpSpPr>
+        <p:cNvPr id="1" name=""/>
+        <p:cNvGrpSpPr/>
+        <p:nvPr/>
+      </p:nvGrpSpPr>
+      <p:grpSpPr>
+        <a:xfrm>
+          <a:off x="0" y="0"/>
+          <a:ext cx="0" cy="0"/>
+          <a:chOff x="0" y="0"/>
+          <a:chExt cx="0" cy="0"/>
+        </a:xfrm>
+      </p:grpSpPr>
+      <p:sp>
+        <p:nvSpPr>
+          <p:cNvPr id="2" name="Slide Image Placeholder 1"/>
+          <p:cNvSpPr>
+            <a:spLocks noGrp="1" noRot="1" noChangeAspect="1"/>
+          </p:cNvSpPr>
+          <p:nvPr>
+            <p:ph type="sldImg" idx="2"/>
+          </p:nvPr>
+        </p:nvSpPr>
+        <p:spPr/>
+      </p:sp>
+      <p:sp>
+        <p:nvSpPr>
+          <p:cNvPr id="3" name="Notes Placeholder 2"/>
+          <p:cNvSpPr>
+            <a:spLocks noGrp="1"/>
+          </p:cNvSpPr>
+          <p:nvPr>
+            <p:ph type="body" sz="quarter" idx="3"/>
+          </p:nvPr>
+        </p:nvSpPr>
+        <p:spPr/>
+        <p:txBody>
+          <a:bodyPr/>
+          <a:lstStyle/>
+          <a:p>
+            <a:r>
+              <a:rPr lang="ko-KR" altLang="en-US" dirty="0"/>
+              <a:t>[약 2분]</a:t>
+            </a:r>
+          </a:p>
+          <a:p>
+            <a:endParaRPr lang="ko-KR" altLang="en-US" dirty="0"/>
+          </a:p>
+          <a:p>
+            <a:r>
+              <a:rPr lang="ko-KR" altLang="en-US" dirty="0"/>
+              <a:t>왼쪽 표가 Gard 접수 현황입니다. 약 70건 중 황분 규제 위반이 12.86%, 인화점 위반이 4.11%, 수량 분쟁이 3%입니다. 나머지 대부분이 품질 문제입니다.</a:t>
+            </a:r>
+          </a:p>
+          <a:p>
+            <a:endParaRPr lang="ko-KR" altLang="en-US" dirty="0"/>
+          </a:p>
+          <a:p>
+            <a:r>
+              <a:rPr lang="ko-KR" altLang="en-US" dirty="0"/>
+              <a:t>주목할 점은 월별 분포입니다. 1~2월보다 3~5월이 뚜렷하게 높고, 이게 중동 분쟁 격화 시점과 겹칩니다. Gard도 인과관계를 단정하지는 않지만, 공급망 압박을 받는 시장에서 나타나는 전형적인 패턴이라고 표현했습니다.</a:t>
+            </a:r>
+          </a:p>
+          <a:p>
+            <a:endParaRPr lang="ko-KR" altLang="en-US" dirty="0"/>
+          </a:p>
+          <a:p>
+            <a:r>
+              <a:rPr lang="ko-KR" altLang="en-US" dirty="0"/>
+              <a:t>오른쪽은 VPS 데이터인데, 여기서 두 가지가 눈에 띕니다.</a:t>
+            </a:r>
+          </a:p>
+          <a:p>
+            <a:endParaRPr lang="ko-KR" altLang="en-US" dirty="0"/>
+          </a:p>
+          <a:p>
+            <a:r>
+              <a:rPr lang="ko-KR" altLang="en-US" dirty="0"/>
+              <a:t>첫째, ULSFO가 28.8%로 압도적입니다. 글로벌 평균 8.8%의 세 배가 넘습니다. ECA 진입 선박이 있으면 이건 별도로 챙겨야 합니다.</a:t>
+            </a:r>
+          </a:p>
+          <a:p>
+            <a:endParaRPr lang="ko-KR" altLang="en-US" dirty="0"/>
+          </a:p>
+          <a:p>
+            <a:r>
+              <a:rPr lang="ko-KR" altLang="en-US" dirty="0"/>
+              <a:t>둘째, 바이오연료가 0.4%로 가장 낮습니다. 통념과 반대죠. 다만 이건 '시험 항목 기준 오프스펙률'이라 낮은 것이고, 바이오의 리스크는 성적서가 아니라 저장·호환성·운영 쪽에 있습니다. 이 얘기는 10번 슬라이드에서 이어가겠습니다.</a:t>
+            </a:r>
+          </a:p>
+          <a:p>
+            <a:endParaRPr lang="ko-KR" altLang="en-US" dirty="0"/>
+          </a:p>
+          <a:p>
+            <a:r>
+              <a:rPr lang="ko-KR" altLang="en-US" dirty="0"/>
+              <a:t>한 가지 주의사항 — 아래 빨간 문장입니다. 클레임 '건수'가 많은 항만이 위험한 항만이라는 뜻은 아닙니다. 싱가포르나 휴스턴은 물동량 자체가 크기 때문에 건수가 많은 것이고, 실제 오프스펙률은 싱가포르가 7.3%로 평균보다 낮습니다. 반대로 로테르담과 안트베르프가 25~29%로 높습니다.</a:t>
+            </a:r>
+          </a:p>
+        </p:txBody>
+      </p:sp>
+      <p:sp>
+        <p:nvSpPr>
+          <p:cNvPr id="4" name="Slide Number Placeholder 3"/>
+          <p:cNvSpPr>
+            <a:spLocks noGrp="1"/>
+          </p:cNvSpPr>
+          <p:nvPr>
+            <p:ph type="sldNum" sz="quarter" idx="5"/>
+          </p:nvPr>
+        </p:nvSpPr>
+        <p:spPr/>
+      </p:sp>
+    </p:spTree>
+  </p:cSld>
+  <p:clrMapOvr>
+    <a:masterClrMapping/>
+  </p:clrMapOvr>
+</p:notes>
+</file>
+
+<file path=ppt/notesSlides/notesSlide4.xml><?xml version="1.0" encoding="utf-8"?>
+<p:notes xmlns:a="http://schemas.openxmlformats.org/drawingml/2006/main" xmlns:r="http://schemas.openxmlformats.org/officeDocument/2006/relationships" xmlns:p="http://schemas.openxmlformats.org/presentationml/2006/main">
+  <p:cSld>
+    <p:spTree>
+      <p:nvGrpSpPr>
+        <p:cNvPr id="1" name=""/>
+        <p:cNvGrpSpPr/>
+        <p:nvPr/>
+      </p:nvGrpSpPr>
+      <p:grpSpPr>
+        <a:xfrm>
+          <a:off x="0" y="0"/>
+          <a:ext cx="0" cy="0"/>
+          <a:chOff x="0" y="0"/>
+          <a:chExt cx="0" cy="0"/>
+        </a:xfrm>
+      </p:grpSpPr>
+      <p:sp>
+        <p:nvSpPr>
+          <p:cNvPr id="2" name="Slide Image Placeholder 1"/>
+          <p:cNvSpPr>
+            <a:spLocks noGrp="1" noRot="1" noChangeAspect="1"/>
+          </p:cNvSpPr>
+          <p:nvPr>
+            <p:ph type="sldImg" idx="2"/>
+          </p:nvPr>
+        </p:nvSpPr>
+        <p:spPr/>
+      </p:sp>
+      <p:sp>
+        <p:nvSpPr>
+          <p:cNvPr id="3" name="Notes Placeholder 2"/>
+          <p:cNvSpPr>
+            <a:spLocks noGrp="1"/>
+          </p:cNvSpPr>
+          <p:nvPr>
+            <p:ph type="body" sz="quarter" idx="3"/>
+          </p:nvPr>
+        </p:nvSpPr>
+        <p:spPr/>
+        <p:txBody>
+          <a:bodyPr/>
+          <a:lstStyle/>
+          <a:p>
+            <a:r>
+              <a:rPr lang="ko-KR" altLang="en-US" dirty="0"/>
+              <a:t>[약 1분 30초]</a:t>
+            </a:r>
+          </a:p>
+          <a:p>
+            <a:endParaRPr lang="ko-KR" altLang="en-US" dirty="0"/>
+          </a:p>
+          <a:p>
+            <a:r>
+              <a:rPr lang="ko-KR" altLang="en-US" dirty="0"/>
+              <a:t>보험 커버별로 보면 절반 이상이 선주 항변비용(Owners' Defence)이고, 40%가 용선자 P&amp;I입니다. 선체기관보험은 6%밖에 안 됩니다.</a:t>
+            </a:r>
+          </a:p>
+          <a:p>
+            <a:endParaRPr lang="ko-KR" altLang="en-US" dirty="0"/>
+          </a:p>
+          <a:p>
+            <a:r>
+              <a:rPr lang="ko-KR" altLang="en-US" dirty="0"/>
+              <a:t>이 분포 자체가 구조를 설명합니다. 정기용선에서는 용선자가 벙커를 수배하고 결제하니까, 문제가 생기면 선주와 용선자 사이 계약 분쟁으로 먼저 터집니다. 선체기관보험까지 가는 건 기관 손상 같은 실물 손해가 났을 때뿐입니다.</a:t>
+            </a:r>
+          </a:p>
+          <a:p>
+            <a:endParaRPr lang="ko-KR" altLang="en-US" dirty="0"/>
+          </a:p>
+          <a:p>
+            <a:r>
+              <a:rPr lang="ko-KR" altLang="en-US" dirty="0"/>
+              <a:t>긍정적인 부분도 있습니다. 분석 결과를 받자마자 짧은 시효 때문에 즉시 용선자나 공급자에게 통지한 선주가 다수였습니다. 이건 우리도 유지해야 할 관행입니다.</a:t>
+            </a:r>
+          </a:p>
+          <a:p>
+            <a:endParaRPr lang="ko-KR" altLang="en-US" dirty="0"/>
+          </a:p>
+          <a:p>
+            <a:r>
+              <a:rPr lang="ko-KR" altLang="en-US" dirty="0"/>
+              <a:t>오른쪽이 진짜 문제입니다. 용선계약과 공급계약, 이 두 계약이 서로 정렬되어 있지 않습니다. 용선계약은 인도 시점에 매니폴드에서 뜬 샘플을 기준으로 삼는데, 공급자 약관은 바지 쪽 리테인 샘플을 최종이라고 규정하는 경우가 많습니다. 같은 스템인데 기준 샘플이 다른 겁니다.</a:t>
+            </a:r>
+          </a:p>
+          <a:p>
+            <a:endParaRPr lang="ko-KR" altLang="en-US" dirty="0"/>
+          </a:p>
+          <a:p>
+            <a:r>
+              <a:rPr lang="ko-KR" altLang="en-US" dirty="0"/>
+              <a:t>그래서 용선자가 두 계약의 교차점에서 가장 큰 노출을 집니다. 선주에게는 책임을 지면서, 공급자에게는 구제받을 길이 제한적인 위치죠.</a:t>
+            </a:r>
+          </a:p>
+          <a:p>
+            <a:endParaRPr lang="ko-KR" altLang="en-US" dirty="0"/>
+          </a:p>
+          <a:p>
+            <a:r>
+              <a:rPr lang="ko-KR" altLang="en-US" dirty="0"/>
+              <a:t>라이너나 대형선주처럼 직접 구매하면 이 미스매치는 없어지지만, 대신 공급자가 작성한 약관을 그대로 받아야 합니다. 결국 샘플링과 시험 조항을 개별 협상하는 게 핵심입니다.</a:t>
+            </a:r>
+          </a:p>
+        </p:txBody>
+      </p:sp>
+      <p:sp>
+        <p:nvSpPr>
+          <p:cNvPr id="4" name="Slide Number Placeholder 3"/>
+          <p:cNvSpPr>
+            <a:spLocks noGrp="1"/>
+          </p:cNvSpPr>
+          <p:nvPr>
+            <p:ph type="sldNum" sz="quarter" idx="5"/>
+          </p:nvPr>
+        </p:nvSpPr>
+        <p:spPr/>
+      </p:sp>
+    </p:spTree>
+  </p:cSld>
+  <p:clrMapOvr>
+    <a:masterClrMapping/>
+  </p:clrMapOvr>
+</p:notes>
+</file>
+
+<file path=ppt/notesSlides/notesSlide5.xml><?xml version="1.0" encoding="utf-8"?>
+<p:notes xmlns:a="http://schemas.openxmlformats.org/drawingml/2006/main" xmlns:r="http://schemas.openxmlformats.org/officeDocument/2006/relationships" xmlns:p="http://schemas.openxmlformats.org/presentationml/2006/main">
+  <p:cSld>
+    <p:spTree>
+      <p:nvGrpSpPr>
+        <p:cNvPr id="1" name=""/>
+        <p:cNvGrpSpPr/>
+        <p:nvPr/>
+      </p:nvGrpSpPr>
+      <p:grpSpPr>
+        <a:xfrm>
+          <a:off x="0" y="0"/>
+          <a:ext cx="0" cy="0"/>
+          <a:chOff x="0" y="0"/>
+          <a:chExt cx="0" cy="0"/>
+        </a:xfrm>
+      </p:grpSpPr>
+      <p:sp>
+        <p:nvSpPr>
+          <p:cNvPr id="2" name="Slide Image Placeholder 1"/>
+          <p:cNvSpPr>
+            <a:spLocks noGrp="1" noRot="1" noChangeAspect="1"/>
+          </p:cNvSpPr>
+          <p:nvPr>
+            <p:ph type="sldImg" idx="2"/>
+          </p:nvPr>
+        </p:nvSpPr>
+        <p:spPr/>
+      </p:sp>
+      <p:sp>
+        <p:nvSpPr>
+          <p:cNvPr id="3" name="Notes Placeholder 2"/>
+          <p:cNvSpPr>
+            <a:spLocks noGrp="1"/>
+          </p:cNvSpPr>
+          <p:nvPr>
+            <p:ph type="body" sz="quarter" idx="3"/>
+          </p:nvPr>
+        </p:nvSpPr>
+        <p:spPr/>
+        <p:txBody>
+          <a:bodyPr/>
+          <a:lstStyle/>
+          <a:p>
+            <a:r>
+              <a:rPr lang="ko-KR" altLang="en-US" dirty="0"/>
+              <a:t>[약 2분 · 오늘 진단의 핵심]</a:t>
+            </a:r>
+          </a:p>
+          <a:p>
+            <a:endParaRPr lang="ko-KR" altLang="en-US" dirty="0"/>
+          </a:p>
+          <a:p>
+            <a:r>
+              <a:rPr lang="ko-KR" altLang="en-US" dirty="0"/>
+              <a:t>Gard 경험상 클레임은 두 갈래입니다.</a:t>
+            </a:r>
+          </a:p>
+          <a:p>
+            <a:endParaRPr lang="ko-KR" altLang="en-US" dirty="0"/>
+          </a:p>
+          <a:p>
+            <a:r>
+              <a:rPr lang="ko-KR" altLang="en-US" dirty="0"/>
+              <a:t>60%는 Table 2 파라미터 자체가 오프스펙인 경우입니다. 총침전물이나 캣파인 같은 것들이죠. 그런데 이 중 상당수는 다른 유해 물질도 함께 있었을 것으로 의심됩니다.</a:t>
+            </a:r>
+          </a:p>
+          <a:p>
+            <a:endParaRPr lang="ko-KR" altLang="en-US" dirty="0"/>
+          </a:p>
+          <a:p>
+            <a:r>
+              <a:rPr lang="ko-KR" altLang="en-US" dirty="0"/>
+              <a:t>40%는 Table 2를 전부 통과했는데도 문제가 된 경우입니다. 이 40%가 지금 업계가 씨름하고 있는 영역입니다.</a:t>
+            </a:r>
+          </a:p>
+          <a:p>
+            <a:endParaRPr lang="ko-KR" altLang="en-US" dirty="0"/>
+          </a:p>
+          <a:p>
+            <a:r>
+              <a:rPr lang="ko-KR" altLang="en-US" dirty="0"/>
+              <a:t>여기에 적용되는 게 ISO 8217 Clause 5입니다. 조항 자체는 간단합니다 — 연료는 선박이나 인명에 유해한 물질을 포함해서는 안 된다. 문제는 입증입니다.</a:t>
+            </a:r>
+          </a:p>
+          <a:p>
+            <a:endParaRPr lang="ko-KR" altLang="en-US" dirty="0"/>
+          </a:p>
+          <a:p>
+            <a:r>
+              <a:rPr lang="ko-KR" altLang="en-US" dirty="0"/>
+              <a:t>오른쪽 세 단계를 보시면, 물질이 있다는 것만으로는 부족하고 그 물질이 실제로 기관이나 안전에 악영향을 줬다는 인과관계까지 보여야 합니다. 그런데 표준 시험법으로는 이런 물질이 잡히지 않습니다. GCMS 같은 탐색적 분석이나 별도 포렌식이 필요하고, 비용과 시간이 듭니다.</a:t>
+            </a:r>
+          </a:p>
+          <a:p>
+            <a:endParaRPr lang="ko-KR" altLang="en-US" dirty="0"/>
+          </a:p>
+          <a:p>
+            <a:r>
+              <a:rPr lang="ko-KR" altLang="en-US" dirty="0"/>
+              <a:t>다행히 ISO 8217:2024 Annex B가 이 부분을 명확히 했습니다. 화학종과 운항 문제 사이에 사실적 인과관계가 입증되면 그 연료는 규격을 충족하지 못한 것으로 본다고 명시했습니다. 입증 부담은 여전하지만 근거는 생긴 셈입니다.</a:t>
+            </a:r>
+          </a:p>
+          <a:p>
+            <a:endParaRPr lang="ko-KR" altLang="en-US" dirty="0"/>
+          </a:p>
+          <a:p>
+            <a:r>
+              <a:rPr lang="ko-KR" altLang="en-US" dirty="0"/>
+              <a:t>실무적으로는 양측이 합의해서 시험 소모나 연료 처리를 해보기도 합니다. 실물 증거가 되지만 운항 리스크가 따르고, 기록을 철저히 남겨야 합니다. 그게 어려우면 전문가 의견에 의존하는데, 전문가마다 견해가 갈려서 Gard 표현으로는 '과학이라기보다 예술에 가까울 때도 있다'고 합니다.</a:t>
+            </a:r>
+          </a:p>
+          <a:p>
+            <a:endParaRPr lang="ko-KR" altLang="en-US" dirty="0"/>
+          </a:p>
+          <a:p>
+            <a:r>
+              <a:rPr lang="ko-KR" altLang="en-US" dirty="0"/>
+              <a:t>왼쪽 아래 빨간 문장도 짚고 넘어가겠습니다. 계약이 참조하는 ISO 버전이 제각각인데, 2017년판이 절반 이상이고 2024년판 전환은 느립니다. 그리고 이번에 가장 큰 손해가 난 사례가 2005년판 기준 계약이었습니다.</a:t>
+            </a:r>
+          </a:p>
+        </p:txBody>
+      </p:sp>
+      <p:sp>
+        <p:nvSpPr>
+          <p:cNvPr id="4" name="Slide Number Placeholder 3"/>
+          <p:cNvSpPr>
+            <a:spLocks noGrp="1"/>
+          </p:cNvSpPr>
+          <p:nvPr>
+            <p:ph type="sldNum" sz="quarter" idx="5"/>
+          </p:nvPr>
+        </p:nvSpPr>
+        <p:spPr/>
+      </p:sp>
+    </p:spTree>
+  </p:cSld>
+  <p:clrMapOvr>
+    <a:masterClrMapping/>
+  </p:clrMapOvr>
+</p:notes>
+</file>
+
+<file path=ppt/notesSlides/notesSlide6.xml><?xml version="1.0" encoding="utf-8"?>
+<p:notes xmlns:a="http://schemas.openxmlformats.org/drawingml/2006/main" xmlns:r="http://schemas.openxmlformats.org/officeDocument/2006/relationships" xmlns:p="http://schemas.openxmlformats.org/presentationml/2006/main">
+  <p:cSld>
+    <p:spTree>
+      <p:nvGrpSpPr>
+        <p:cNvPr id="1" name=""/>
+        <p:cNvGrpSpPr/>
+        <p:nvPr/>
+      </p:nvGrpSpPr>
+      <p:grpSpPr>
+        <a:xfrm>
+          <a:off x="0" y="0"/>
+          <a:ext cx="0" cy="0"/>
+          <a:chOff x="0" y="0"/>
+          <a:chExt cx="0" cy="0"/>
+        </a:xfrm>
+      </p:grpSpPr>
+      <p:sp>
+        <p:nvSpPr>
+          <p:cNvPr id="2" name="Slide Image Placeholder 1"/>
+          <p:cNvSpPr>
+            <a:spLocks noGrp="1" noRot="1" noChangeAspect="1"/>
+          </p:cNvSpPr>
+          <p:nvPr>
+            <p:ph type="sldImg" idx="2"/>
+          </p:nvPr>
+        </p:nvSpPr>
+        <p:spPr/>
+      </p:sp>
+      <p:sp>
+        <p:nvSpPr>
+          <p:cNvPr id="3" name="Notes Placeholder 2"/>
+          <p:cNvSpPr>
+            <a:spLocks noGrp="1"/>
+          </p:cNvSpPr>
+          <p:nvPr>
+            <p:ph type="body" sz="quarter" idx="3"/>
+          </p:nvPr>
+        </p:nvSpPr>
+        <p:spPr/>
+        <p:txBody>
+          <a:bodyPr/>
+          <a:lstStyle/>
+          <a:p>
+            <a:r>
+              <a:rPr lang="ko-KR" altLang="en-US" dirty="0"/>
+              <a:t>[약 2분 · 숫자를 체감으로 바꾸는 슬라이드]</a:t>
+            </a:r>
+          </a:p>
+          <a:p>
+            <a:endParaRPr lang="ko-KR" altLang="en-US" dirty="0"/>
+          </a:p>
+          <a:p>
+            <a:r>
+              <a:rPr lang="ko-KR" altLang="en-US" dirty="0"/>
+              <a:t>Case 1. 안트베르프에서 받은 VLSFO입니다. 유기산이 6,000ppm을 넘었습니다. 실린더 두 기에 고온 경보가 뜨더니 피스톤링과 라이너가 눌어붙었고, 나머지 실린더에서도 심한 마모가 확인되면서 주기관 전체가 멈췄습니다. 3일간 표류하고 4일간 예인했습니다. 공동해손을 선언했고 화물을 환적했으며, 탱크를 전부 비우고 세정했습니다. 수리에 4주, 비용은 약 50만 달러입니다. 그런데 이 연료, Table 2는 전부 통과했습니다. 참고로 다른 건에서는 예인만 3주 걸린 사례도 있습니다.</a:t>
+            </a:r>
+          </a:p>
+          <a:p>
+            <a:endParaRPr lang="ko-KR" altLang="en-US" dirty="0"/>
+          </a:p>
+          <a:p>
+            <a:r>
+              <a:rPr lang="ko-KR" altLang="en-US" dirty="0"/>
+              <a:t>Case 2. 싱가포르 스템입니다. 싱가포르 해협 통항 중 연료유 저압 경보가 울렸습니다. 발전기는 MGO 라인으로 전환해서 넘겼는데, 주기관 쪽 자동역세척 필터가 청소 속도를 못 따라갈 정도로 빨리 막혔습니다. 나중에 분석해 보니 카돌과 레조르시놀이 22,000ppm 넘게 검출됐습니다. 결국 디벙커링했습니다. 이것도 Table 2는 준수했다고 보고됐습니다.</a:t>
+            </a:r>
+          </a:p>
+          <a:p>
+            <a:endParaRPr lang="ko-KR" altLang="en-US" dirty="0"/>
+          </a:p>
+          <a:p>
+            <a:r>
+              <a:rPr lang="ko-KR" altLang="en-US" dirty="0"/>
+              <a:t>Case 3. 이게 두 리포트를 직접 연결하는 사례입니다. ULSFO와 B30 CNSL 블렌드가 든 탱크로 전환하고 약 이틀 뒤, 도선사 승선을 기다리며 표류하던 중에 추진력을 잃었습니다. 검정인 예비 조사에서 연료 분사기와 펌프 손상이 불량 연료, 특히 캐슈넛 껍질 오일 오염 때문이라고 나왔습니다.</a:t>
+            </a:r>
+          </a:p>
+          <a:p>
+            <a:endParaRPr lang="ko-KR" altLang="en-US" dirty="0"/>
+          </a:p>
+          <a:p>
+            <a:r>
+              <a:rPr lang="ko-KR" altLang="en-US" dirty="0"/>
+              <a:t>CNSL은 잠시 뒤 SSA 문서에서 다시 나옵니다. 거기서는 '허용되는 non-FAME 대안'으로 소개되거든요. 같은 물질이 한쪽에서는 대안이고 한쪽에서는 사고 원인입니다. 그 간극이 오늘 결정 사항 1번입니다.</a:t>
+            </a:r>
+          </a:p>
+          <a:p>
+            <a:endParaRPr lang="ko-KR" altLang="en-US" dirty="0"/>
+          </a:p>
+          <a:p>
+            <a:r>
+              <a:rPr lang="ko-KR" altLang="en-US" dirty="0"/>
+              <a:t>오른쪽 표는 여러 클레임에서 공통으로 나온 증상입니다. 필터와 청정기 급속 막힘, 끈적한 슬러지와 탄화물, 플런저·피스톤링 마모. 이 셋 중 하나라도 보고되면 연료를 의심하고 즉시 샘플을 확보해야 합니다.</a:t>
+            </a:r>
+          </a:p>
+        </p:txBody>
+      </p:sp>
+      <p:sp>
+        <p:nvSpPr>
+          <p:cNvPr id="4" name="Slide Number Placeholder 3"/>
+          <p:cNvSpPr>
+            <a:spLocks noGrp="1"/>
+          </p:cNvSpPr>
+          <p:nvPr>
+            <p:ph type="sldNum" sz="quarter" idx="5"/>
+          </p:nvPr>
+        </p:nvSpPr>
+        <p:spPr/>
+      </p:sp>
+    </p:spTree>
+  </p:cSld>
+  <p:clrMapOvr>
+    <a:masterClrMapping/>
+  </p:clrMapOvr>
+</p:notes>
+</file>
+
+<file path=ppt/notesSlides/notesSlide7.xml><?xml version="1.0" encoding="utf-8"?>
+<p:notes xmlns:a="http://schemas.openxmlformats.org/drawingml/2006/main" xmlns:r="http://schemas.openxmlformats.org/officeDocument/2006/relationships" xmlns:p="http://schemas.openxmlformats.org/presentationml/2006/main">
+  <p:cSld>
+    <p:spTree>
+      <p:nvGrpSpPr>
+        <p:cNvPr id="1" name=""/>
+        <p:cNvGrpSpPr/>
+        <p:nvPr/>
+      </p:nvGrpSpPr>
+      <p:grpSpPr>
+        <a:xfrm>
+          <a:off x="0" y="0"/>
+          <a:ext cx="0" cy="0"/>
+          <a:chOff x="0" y="0"/>
+          <a:chExt cx="0" cy="0"/>
+        </a:xfrm>
+      </p:grpSpPr>
+      <p:sp>
+        <p:nvSpPr>
+          <p:cNvPr id="2" name="Slide Image Placeholder 1"/>
+          <p:cNvSpPr>
+            <a:spLocks noGrp="1" noRot="1" noChangeAspect="1"/>
+          </p:cNvSpPr>
+          <p:nvPr>
+            <p:ph type="sldImg" idx="2"/>
+          </p:nvPr>
+        </p:nvSpPr>
+        <p:spPr/>
+      </p:sp>
+      <p:sp>
+        <p:nvSpPr>
+          <p:cNvPr id="3" name="Notes Placeholder 2"/>
+          <p:cNvSpPr>
+            <a:spLocks noGrp="1"/>
+          </p:cNvSpPr>
+          <p:nvPr>
+            <p:ph type="body" sz="quarter" idx="3"/>
+          </p:nvPr>
+        </p:nvSpPr>
+        <p:spPr/>
+        <p:txBody>
+          <a:bodyPr/>
+          <a:lstStyle/>
+          <a:p>
+            <a:r>
+              <a:rPr lang="ko-KR" altLang="en-US" dirty="0"/>
+              <a:t>[약 1분 30초]</a:t>
+            </a:r>
+          </a:p>
+          <a:p>
+            <a:endParaRPr lang="ko-KR" altLang="en-US" dirty="0"/>
+          </a:p>
+          <a:p>
+            <a:r>
+              <a:rPr lang="ko-KR" altLang="en-US" dirty="0"/>
+              <a:t>품질과 별개로, 규제 수치를 넘기면 그 순간 배가 묶입니다.</a:t>
+            </a:r>
+          </a:p>
+          <a:p>
+            <a:endParaRPr lang="ko-KR" altLang="en-US" dirty="0"/>
+          </a:p>
+          <a:p>
+            <a:r>
+              <a:rPr lang="ko-KR" altLang="en-US" dirty="0"/>
+              <a:t>황분이 전체 클레임의 12.86%입니다. 대부분 VLSFO가 0.5% 한도를 넘긴 건데, 심한 경우 2.7%까지 나왔습니다. 일부는 스크러버 장착선의 HSFO가 3.5%를, ECA 내 ULSFO가 0.1%를 넘긴 경우입니다.</a:t>
+            </a:r>
+          </a:p>
+          <a:p>
+            <a:endParaRPr lang="ko-KR" altLang="en-US" dirty="0"/>
+          </a:p>
+          <a:p>
+            <a:r>
+              <a:rPr lang="ko-KR" altLang="en-US" dirty="0"/>
+              <a:t>중국 사례를 보시면 문제가 더 복잡해집니다. MSA 정기 점검에서 2%가 넘게 나왔고, 당국이 해당 탱크를 봉인해서 디벙커링과 세정 전까지 사용을 막았습니다. 그런데 그 시점에 이미 정기용선자가 재인도를 마친 뒤였습니다. 제거 비용과 세정 비용을 누가 부담하느냐가 계약상 큰 쟁점이 됐습니다.</a:t>
+            </a:r>
+          </a:p>
+          <a:p>
+            <a:endParaRPr lang="ko-KR" altLang="en-US" dirty="0"/>
+          </a:p>
+          <a:p>
+            <a:r>
+              <a:rPr lang="ko-KR" altLang="en-US" dirty="0"/>
+              <a:t>참고로, 자체 분석에서 부적합이 나오면 선장은 기국, 목적항 당국, 공급자 관할 당국, 그리고 공급자 본인에게 공식 통지해야 합니다. 항만국통제가 이 부분을 확인할 수 있습니다.</a:t>
+            </a:r>
+          </a:p>
+          <a:p>
+            <a:endParaRPr lang="ko-KR" altLang="en-US" dirty="0"/>
+          </a:p>
+          <a:p>
+            <a:r>
+              <a:rPr lang="ko-KR" altLang="en-US" dirty="0"/>
+              <a:t>인화점은 4.11%입니다. SOLAS상 선내 사용 연료는 60도 이상이어야 합니다. 사례에서는 공동 시험에서도 60도 미만이 확인돼서 전량 디벙커링했습니다.</a:t>
+            </a:r>
+          </a:p>
+          <a:p>
+            <a:endParaRPr lang="ko-KR" altLang="en-US" dirty="0"/>
+          </a:p>
+          <a:p>
+            <a:r>
+              <a:rPr lang="ko-KR" altLang="en-US" dirty="0"/>
+              <a:t>아래 회색 박스가 실무적으로 챙겨야 할 변경입니다. 올해 1월 SOLAS 개정으로 사전 벙커링 신고와 BDN이 의무화됐고, BDN에 인화점 실측치를 적거나 70도 이상이라고 명시해야 합니다. 벙커링 전에 확인할 수 있게 된 겁니다.</a:t>
+            </a:r>
+          </a:p>
+          <a:p>
+            <a:endParaRPr lang="ko-KR" altLang="en-US" dirty="0"/>
+          </a:p>
+          <a:p>
+            <a:r>
+              <a:rPr lang="ko-KR" altLang="en-US" dirty="0"/>
+              <a:t>오른쪽은 수량 쪽입니다. ARA에서 질량유량계가 의무화되면서 3% 정도가 수량 분쟁입니다. 사례에서는 BDN보다 60톤이 적게 들어왔는데, 검정인과 선원이 바지 수동 검척을 거부당했고 교정증은 16개월이 지나 있었습니다. 당국은 상업 분쟁에 개입하지 않는다는 입장이라, 결국 선상에서 검증 기회를 확보했느냐가 클레임의 강도를 결정합니다.</a:t>
+            </a:r>
+          </a:p>
+        </p:txBody>
+      </p:sp>
+      <p:sp>
+        <p:nvSpPr>
+          <p:cNvPr id="4" name="Slide Number Placeholder 3"/>
+          <p:cNvSpPr>
+            <a:spLocks noGrp="1"/>
+          </p:cNvSpPr>
+          <p:nvPr>
+            <p:ph type="sldNum" sz="quarter" idx="5"/>
+          </p:nvPr>
+        </p:nvSpPr>
+        <p:spPr/>
+      </p:sp>
+    </p:spTree>
+  </p:cSld>
+  <p:clrMapOvr>
+    <a:masterClrMapping/>
+  </p:clrMapOvr>
+</p:notes>
+</file>
+
+<file path=ppt/notesSlides/notesSlide8.xml><?xml version="1.0" encoding="utf-8"?>
+<p:notes xmlns:a="http://schemas.openxmlformats.org/drawingml/2006/main" xmlns:r="http://schemas.openxmlformats.org/officeDocument/2006/relationships" xmlns:p="http://schemas.openxmlformats.org/presentationml/2006/main">
+  <p:cSld>
+    <p:spTree>
+      <p:nvGrpSpPr>
+        <p:cNvPr id="1" name=""/>
+        <p:cNvGrpSpPr/>
+        <p:nvPr/>
+      </p:nvGrpSpPr>
+      <p:grpSpPr>
+        <a:xfrm>
+          <a:off x="0" y="0"/>
+          <a:ext cx="0" cy="0"/>
+          <a:chOff x="0" y="0"/>
+          <a:chExt cx="0" cy="0"/>
+        </a:xfrm>
+      </p:grpSpPr>
+      <p:sp>
+        <p:nvSpPr>
+          <p:cNvPr id="2" name="Slide Image Placeholder 1"/>
+          <p:cNvSpPr>
+            <a:spLocks noGrp="1" noRot="1" noChangeAspect="1"/>
+          </p:cNvSpPr>
+          <p:nvPr>
+            <p:ph type="sldImg" idx="2"/>
+          </p:nvPr>
+        </p:nvSpPr>
+        <p:spPr/>
+      </p:sp>
+      <p:sp>
+        <p:nvSpPr>
+          <p:cNvPr id="3" name="Notes Placeholder 2"/>
+          <p:cNvSpPr>
+            <a:spLocks noGrp="1"/>
+          </p:cNvSpPr>
+          <p:nvPr>
+            <p:ph type="body" sz="quarter" idx="3"/>
+          </p:nvPr>
+        </p:nvSpPr>
+        <p:spPr/>
+        <p:txBody>
+          <a:bodyPr/>
+          <a:lstStyle/>
+          <a:p>
+            <a:r>
+              <a:rPr lang="ko-KR" altLang="en-US" dirty="0"/>
+              <a:t>[약 1분 30초]</a:t>
+            </a:r>
+          </a:p>
+          <a:p>
+            <a:endParaRPr lang="ko-KR" altLang="en-US" dirty="0"/>
+          </a:p>
+          <a:p>
+            <a:r>
+              <a:rPr lang="ko-KR" altLang="en-US" dirty="0"/>
+              <a:t>여기가 '이길 수 있느냐'를 가르는 지점입니다.</a:t>
+            </a:r>
+          </a:p>
+          <a:p>
+            <a:endParaRPr lang="ko-KR" altLang="en-US" dirty="0"/>
+          </a:p>
+          <a:p>
+            <a:r>
+              <a:rPr lang="ko-KR" altLang="en-US" dirty="0"/>
+              <a:t>핵심 쟁점은 어느 샘플이 구속력을 갖느냐입니다. 앞에서 말씀드린 대로 용선계약과 공급자 약관이 서로 다른 샘플을 지정하는 경우가 많습니다.</a:t>
+            </a:r>
+          </a:p>
+          <a:p>
+            <a:endParaRPr lang="ko-KR" altLang="en-US" dirty="0"/>
+          </a:p>
+          <a:p>
+            <a:r>
+              <a:rPr lang="ko-KR" altLang="en-US" dirty="0"/>
+              <a:t>샘플 무결성 문제도 실제로 있었습니다. 한 건에서는 검정인이 공급자 리테인 샘플의 봉인 링이 빠지고 구멍이 난 걸 발견했습니다. 선박 매니폴드와 탱크 샘플에서는 캣파인이 200mg/kg, 나트륨이 500mg/kg을 넘었는데 공급자 샘플은 품질증명서와 똑같이 온스펙이었습니다. 결국 당국에 정식 신고했습니다. 3D 프린팅으로 봉인을 복제한다는 얘기도 돌지만 Gard가 다룬 사건에서 입증된 적은 없습니다.</a:t>
+            </a:r>
+          </a:p>
+          <a:p>
+            <a:endParaRPr lang="ko-KR" altLang="en-US" dirty="0"/>
+          </a:p>
+          <a:p>
+            <a:r>
+              <a:rPr lang="ko-KR" altLang="en-US" dirty="0"/>
+              <a:t>공급자들은 오프스펙이 난 항목 하나만 시험하자고 제안하는 경우가 많습니다. 이건 거절해야 합니다. 그 샘플이 실제 인도된 연료를 대표하는지 알 수 없게 되고, 앞선 분석에서 더 넓은 문제가 시사됐을 때 특히 그렇습니다. 전체 화학 프로파일, 즉 fingerprinting을 확보해야 샘플 간 비교가 가능해집니다.</a:t>
+            </a:r>
+          </a:p>
+          <a:p>
+            <a:endParaRPr lang="ko-KR" altLang="en-US" dirty="0"/>
+          </a:p>
+          <a:p>
+            <a:r>
+              <a:rPr lang="ko-KR" altLang="en-US" dirty="0"/>
+              <a:t>오른쪽 다섯 가지는 분쟁이 나기 전에 계약서에 박아둬야 할 항목입니다. 특히 3번 공동시험 프로토콜 — 보관 사슬, 연구소, 입회 방법, 시험법을 미리 합의해두지 않으면 본안은 시작도 못 하고 증거 다툼만 길어집니다.</a:t>
+            </a:r>
+          </a:p>
+        </p:txBody>
+      </p:sp>
+      <p:sp>
+        <p:nvSpPr>
+          <p:cNvPr id="4" name="Slide Number Placeholder 3"/>
+          <p:cNvSpPr>
+            <a:spLocks noGrp="1"/>
+          </p:cNvSpPr>
+          <p:nvPr>
+            <p:ph type="sldNum" sz="quarter" idx="5"/>
+          </p:nvPr>
+        </p:nvSpPr>
+        <p:spPr/>
+      </p:sp>
+    </p:spTree>
+  </p:cSld>
+  <p:clrMapOvr>
+    <a:masterClrMapping/>
+  </p:clrMapOvr>
+</p:notes>
+</file>
+
+<file path=ppt/notesSlides/notesSlide9.xml><?xml version="1.0" encoding="utf-8"?>
+<p:notes xmlns:a="http://schemas.openxmlformats.org/drawingml/2006/main" xmlns:r="http://schemas.openxmlformats.org/officeDocument/2006/relationships" xmlns:p="http://schemas.openxmlformats.org/presentationml/2006/main">
+  <p:cSld>
+    <p:spTree>
+      <p:nvGrpSpPr>
+        <p:cNvPr id="1" name=""/>
+        <p:cNvGrpSpPr/>
+        <p:nvPr/>
+      </p:nvGrpSpPr>
+      <p:grpSpPr>
+        <a:xfrm>
+          <a:off x="0" y="0"/>
+          <a:ext cx="0" cy="0"/>
+          <a:chOff x="0" y="0"/>
+          <a:chExt cx="0" cy="0"/>
+        </a:xfrm>
+      </p:grpSpPr>
+      <p:sp>
+        <p:nvSpPr>
+          <p:cNvPr id="2" name="Slide Image Placeholder 1"/>
+          <p:cNvSpPr>
+            <a:spLocks noGrp="1" noRot="1" noChangeAspect="1"/>
+          </p:cNvSpPr>
+          <p:nvPr>
+            <p:ph type="sldImg" idx="2"/>
+          </p:nvPr>
+        </p:nvSpPr>
+        <p:spPr/>
+      </p:sp>
+      <p:sp>
+        <p:nvSpPr>
+          <p:cNvPr id="3" name="Notes Placeholder 2"/>
+          <p:cNvSpPr>
+            <a:spLocks noGrp="1"/>
+          </p:cNvSpPr>
+          <p:nvPr>
+            <p:ph type="body" sz="quarter" idx="3"/>
+          </p:nvPr>
+        </p:nvSpPr>
+        <p:spPr/>
+        <p:txBody>
+          <a:bodyPr/>
+          <a:lstStyle/>
+          <a:p>
+            <a:r>
+              <a:rPr lang="ko-KR" altLang="en-US" dirty="0"/>
+              <a:t>[약 1분 30초 · 여기서 두 번째 문서로 넘어감]</a:t>
+            </a:r>
+          </a:p>
+          <a:p>
+            <a:endParaRPr lang="ko-KR" altLang="en-US" dirty="0"/>
+          </a:p>
+          <a:p>
+            <a:r>
+              <a:rPr lang="ko-KR" altLang="en-US" dirty="0"/>
+              <a:t>여기서부터 SSA 문서입니다.</a:t>
+            </a:r>
+          </a:p>
+          <a:p>
+            <a:endParaRPr lang="ko-KR" altLang="en-US" dirty="0"/>
+          </a:p>
+          <a:p>
+            <a:r>
+              <a:rPr lang="ko-KR" altLang="en-US" dirty="0"/>
+              <a:t>싱가포르 바이오 블렌드 판매가 2025년에 약 1.3백만 톤, 전년 대비 53% 증가했습니다. 2024년에도 68% 늘었으니 2년 연속 폭발적인 성장입니다. 그 결과 로테르담의 63.5만 톤을 넘어서면서 아시아태평양이 세계 최대 바이오 벙커링 지역이 됐습니다.</a:t>
+            </a:r>
+          </a:p>
+          <a:p>
+            <a:endParaRPr lang="ko-KR" altLang="en-US" dirty="0"/>
+          </a:p>
+          <a:p>
+            <a:r>
+              <a:rPr lang="ko-KR" altLang="en-US" dirty="0"/>
+              <a:t>각주 하나 말씀드리면, SSA 문서 안에서도 서문은 1.36백만 톤, FAQ 31은 1.33백만 톤으로 숫자가 조금 다릅니다. 그래서 저는 '약 1.3백만 톤'으로 통일했습니다.</a:t>
+            </a:r>
+          </a:p>
+          <a:p>
+            <a:endParaRPr lang="ko-KR" altLang="en-US" dirty="0"/>
+          </a:p>
+          <a:p>
+            <a:r>
+              <a:rPr lang="ko-KR" altLang="en-US" dirty="0"/>
+              <a:t>수요를 만드는 건 IMO가 아니라 EU입니다. FuelEU Maritime이 2025년 1월부터 시행되면서 벙커 구매 방식이 바뀌었습니다. 예전엔 가격 최적화였는데 지금은 규제 준수 조달입니다. 페널티나 풀링 복잡성을 피하려고 선주들이 비싼 바이오 블렌드를 감수하고 있습니다. 반면 IMO 넷제로 프레임워크는 2025년 10월에 연기되면서 단기 수요에는 거의 영향이 없습니다.</a:t>
+            </a:r>
+          </a:p>
+          <a:p>
+            <a:endParaRPr lang="ko-KR" altLang="en-US" dirty="0"/>
+          </a:p>
+          <a:p>
+            <a:r>
+              <a:rPr lang="ko-KR" altLang="en-US" dirty="0"/>
+              <a:t>공급 쪽 제약도 봐야 합니다. 전 세계 폐식용유가 1,100~1,200만 톤인데, 그중 마린 바이오디젤로 가는 건 37만 톤 정도입니다. 나머지는 항공 SAF와 HVO 쪽으로 갑니다. 같은 원료를 놓고 항공·육상운송과 경쟁하니까 인증 UCOME 확보가 어려워지고 가격 변동성이 커집니다.</a:t>
+            </a:r>
+          </a:p>
+          <a:p>
+            <a:endParaRPr lang="ko-KR" altLang="en-US" dirty="0"/>
+          </a:p>
+          <a:p>
+            <a:r>
+              <a:rPr lang="ko-KR" altLang="en-US" dirty="0"/>
+              <a:t>가격은 VLSFO 대비 톤당 200달러대 프리미엄이 구조적으로 유지되고 있습니다. 그리고 바이오 자체 수급보다 원유와 VLSFO 가격에 연동해서 움직입니다. 수요가 약할 때도 가격이 떨어지기보다 프리미엄만 좁아지는 형태로 조정됩니다.</a:t>
+            </a:r>
+          </a:p>
+        </p:txBody>
+      </p:sp>
+      <p:sp>
+        <p:nvSpPr>
+          <p:cNvPr id="4" name="Slide Number Placeholder 3"/>
+          <p:cNvSpPr>
+            <a:spLocks noGrp="1"/>
+          </p:cNvSpPr>
+          <p:nvPr>
+            <p:ph type="sldNum" sz="quarter" idx="5"/>
+          </p:nvPr>
+        </p:nvSpPr>
+        <p:spPr/>
+      </p:sp>
+    </p:spTree>
   </p:cSld>
   <p:clrMapOvr>
     <a:masterClrMapping/>

</xml_diff>